<commit_message>
docs(tfg): correct use-case actors in defense deck
</commit_message>
<xml_diff>
--- a/tfg/presentacion/entrega/TransitOps_Presentacion_TFG.pptx
+++ b/tfg/presentacion/entrega/TransitOps_Presentacion_TFG.pptx
@@ -2,34 +2,34 @@
 <file path=ppt/presentation.xml><?xml version="1.0" encoding="utf-8"?>
 <p:presentation xmlns:p="http://schemas.openxmlformats.org/presentationml/2006/main">
   <p:sldMasterIdLst>
-    <p:sldMasterId xmlns:r="http://schemas.openxmlformats.org/officeDocument/2006/relationships" id="2147483648" r:id="Rd9d8e93ed0dc44e8"/>
+    <p:sldMasterId xmlns:r="http://schemas.openxmlformats.org/officeDocument/2006/relationships" id="2147483648" r:id="R644b922e9ef442d8"/>
   </p:sldMasterIdLst>
   <p:notesMasterIdLst>
-    <p:notesMasterId xmlns:r="http://schemas.openxmlformats.org/officeDocument/2006/relationships" r:id="Rce0f257a42fc42dc"/>
+    <p:notesMasterId xmlns:r="http://schemas.openxmlformats.org/officeDocument/2006/relationships" r:id="Rb90386bbc6e2454d"/>
   </p:notesMasterIdLst>
   <p:sldIdLst>
-    <p:sldId xmlns:r="http://schemas.openxmlformats.org/officeDocument/2006/relationships" id="256" r:id="R1e033a4619804b26"/>
-    <p:sldId xmlns:r="http://schemas.openxmlformats.org/officeDocument/2006/relationships" id="257" r:id="Rd181730703a8493c"/>
-    <p:sldId xmlns:r="http://schemas.openxmlformats.org/officeDocument/2006/relationships" id="258" r:id="Rb1970ca7d6784113"/>
-    <p:sldId xmlns:r="http://schemas.openxmlformats.org/officeDocument/2006/relationships" id="259" r:id="R5f70150faf284216"/>
-    <p:sldId xmlns:r="http://schemas.openxmlformats.org/officeDocument/2006/relationships" id="260" r:id="Rdb7323d2148a471e"/>
-    <p:sldId xmlns:r="http://schemas.openxmlformats.org/officeDocument/2006/relationships" id="261" r:id="R51b7dd9b946d4499"/>
-    <p:sldId xmlns:r="http://schemas.openxmlformats.org/officeDocument/2006/relationships" id="262" r:id="Rcc91203180654d4a"/>
-    <p:sldId xmlns:r="http://schemas.openxmlformats.org/officeDocument/2006/relationships" id="263" r:id="Rd6c7f3939ea645d3"/>
-    <p:sldId xmlns:r="http://schemas.openxmlformats.org/officeDocument/2006/relationships" id="264" r:id="Ra5821322943545e7"/>
-    <p:sldId xmlns:r="http://schemas.openxmlformats.org/officeDocument/2006/relationships" id="265" r:id="R1415732878494294"/>
-    <p:sldId xmlns:r="http://schemas.openxmlformats.org/officeDocument/2006/relationships" id="266" r:id="R6d1d10a3bfdd4f4a"/>
-    <p:sldId xmlns:r="http://schemas.openxmlformats.org/officeDocument/2006/relationships" id="267" r:id="Rbe56884c98c846ef"/>
-    <p:sldId xmlns:r="http://schemas.openxmlformats.org/officeDocument/2006/relationships" id="268" r:id="R081a76e295cb4429"/>
-    <p:sldId xmlns:r="http://schemas.openxmlformats.org/officeDocument/2006/relationships" id="269" r:id="R05e7f712bbf54483"/>
-    <p:sldId xmlns:r="http://schemas.openxmlformats.org/officeDocument/2006/relationships" id="270" r:id="R903f2ea45e8244bf"/>
-    <p:sldId xmlns:r="http://schemas.openxmlformats.org/officeDocument/2006/relationships" id="271" r:id="Red039a20c3fc4752"/>
-    <p:sldId xmlns:r="http://schemas.openxmlformats.org/officeDocument/2006/relationships" id="272" r:id="R19434e94768b4f51"/>
-    <p:sldId xmlns:r="http://schemas.openxmlformats.org/officeDocument/2006/relationships" id="273" r:id="Rb8690b62e2bf4853"/>
-    <p:sldId xmlns:r="http://schemas.openxmlformats.org/officeDocument/2006/relationships" id="274" r:id="Ree2357951edb428f"/>
-    <p:sldId xmlns:r="http://schemas.openxmlformats.org/officeDocument/2006/relationships" id="275" r:id="R577e0bfdc53745a9"/>
-    <p:sldId xmlns:r="http://schemas.openxmlformats.org/officeDocument/2006/relationships" id="276" r:id="R211170b3c47a4c78"/>
-    <p:sldId xmlns:r="http://schemas.openxmlformats.org/officeDocument/2006/relationships" id="277" r:id="R85134336681e4aa7"/>
+    <p:sldId xmlns:r="http://schemas.openxmlformats.org/officeDocument/2006/relationships" id="256" r:id="R4bcd63a8ab744e51"/>
+    <p:sldId xmlns:r="http://schemas.openxmlformats.org/officeDocument/2006/relationships" id="257" r:id="R9f32083f8fa4404e"/>
+    <p:sldId xmlns:r="http://schemas.openxmlformats.org/officeDocument/2006/relationships" id="258" r:id="R6409577c30b94376"/>
+    <p:sldId xmlns:r="http://schemas.openxmlformats.org/officeDocument/2006/relationships" id="259" r:id="R1198e69215774ce1"/>
+    <p:sldId xmlns:r="http://schemas.openxmlformats.org/officeDocument/2006/relationships" id="260" r:id="R6bf2586ded154c56"/>
+    <p:sldId xmlns:r="http://schemas.openxmlformats.org/officeDocument/2006/relationships" id="261" r:id="R908392b39b444d33"/>
+    <p:sldId xmlns:r="http://schemas.openxmlformats.org/officeDocument/2006/relationships" id="262" r:id="R8dedfad9a1ac440f"/>
+    <p:sldId xmlns:r="http://schemas.openxmlformats.org/officeDocument/2006/relationships" id="263" r:id="Rf1fc862c3ad4429f"/>
+    <p:sldId xmlns:r="http://schemas.openxmlformats.org/officeDocument/2006/relationships" id="264" r:id="Rf5860d36deab49ad"/>
+    <p:sldId xmlns:r="http://schemas.openxmlformats.org/officeDocument/2006/relationships" id="265" r:id="R5ede7205e6e643f5"/>
+    <p:sldId xmlns:r="http://schemas.openxmlformats.org/officeDocument/2006/relationships" id="266" r:id="R79a649860856445f"/>
+    <p:sldId xmlns:r="http://schemas.openxmlformats.org/officeDocument/2006/relationships" id="267" r:id="R458fc16315af4c79"/>
+    <p:sldId xmlns:r="http://schemas.openxmlformats.org/officeDocument/2006/relationships" id="268" r:id="R1a511df6297e412f"/>
+    <p:sldId xmlns:r="http://schemas.openxmlformats.org/officeDocument/2006/relationships" id="269" r:id="Rf10308b0907d4fd5"/>
+    <p:sldId xmlns:r="http://schemas.openxmlformats.org/officeDocument/2006/relationships" id="270" r:id="R73c99646b0d749ff"/>
+    <p:sldId xmlns:r="http://schemas.openxmlformats.org/officeDocument/2006/relationships" id="271" r:id="R0f27729e17d44b26"/>
+    <p:sldId xmlns:r="http://schemas.openxmlformats.org/officeDocument/2006/relationships" id="272" r:id="Rff6a8f42157a4b68"/>
+    <p:sldId xmlns:r="http://schemas.openxmlformats.org/officeDocument/2006/relationships" id="273" r:id="Rf5811811fc2546ed"/>
+    <p:sldId xmlns:r="http://schemas.openxmlformats.org/officeDocument/2006/relationships" id="274" r:id="R10fa362e21394323"/>
+    <p:sldId xmlns:r="http://schemas.openxmlformats.org/officeDocument/2006/relationships" id="275" r:id="Rda770a816fb9493e"/>
+    <p:sldId xmlns:r="http://schemas.openxmlformats.org/officeDocument/2006/relationships" id="276" r:id="R618db6b39ed14edc"/>
+    <p:sldId xmlns:r="http://schemas.openxmlformats.org/officeDocument/2006/relationships" id="277" r:id="R19ed90e9c3234e4c"/>
   </p:sldIdLst>
   <p:sldSz cx="12192000" cy="6858000"/>
   <p:notesSz cx="6858000" cy="9144000"/>
@@ -2183,7 +2183,7 @@
           </a:p>
           <a:p xmlns:a="http://schemas.openxmlformats.org/drawingml/2006/main">
             <a:r>
-              <a:t>Cuatro casos de uso organizan el alcance. El primero cubre el acceso y la sesión. El segundo mantiene vehículos, conductores y clientes. El tercero recorre la operación del envío, desde su creación y asignación hasta la entrega o cancelación, con eventos durante el trayecto. El cuarto reúne administración e indicadores. Esta división convierte una lista extensa de requisitos en recorridos demostrables y proporciona la base de las pruebas de sistema.</a:t>
+              <a:t>La memoria define cuatro casos de uso concretos. En CU-1, el instalador crea el primer administrador y el punto de arranque queda bloqueado. En CU-2 intervienen dos roles en momentos distintos: el administrador crea la cuenta y el operador realiza el primer acceso y cambia la contraseña inicial. En CU-3, el operador ejecuta un envío de principio a fin y deja una cronología verificable. En CU-4, el administrador desactiva una cuenta sin borrar la actividad que ya produjo. Operador y administrador son roles separados; la tabla indica quién actúa en cada recorrido.</a:t>
             </a:r>
           </a:p>
           <a:p xmlns:a="http://schemas.openxmlformats.org/drawingml/2006/main">
@@ -2551,7 +2551,7 @@
   </p:cSld>
   <p:clrMap bg1="lt1" tx1="dk1" bg2="lt2" tx2="dk2" accent1="accent1" accent2="accent2" accent3="accent3" accent4="accent4" accent5="accent5" accent6="accent6" hlink="hlink" folHlink="folHlink"/>
   <p:sldLayoutIdLst>
-    <p:sldLayoutId xmlns:r="http://schemas.openxmlformats.org/officeDocument/2006/relationships" id="2147483649" r:id="R43e71046027e41f1"/>
+    <p:sldLayoutId xmlns:r="http://schemas.openxmlformats.org/officeDocument/2006/relationships" id="2147483649" r:id="R00bdf21ffc864094"/>
   </p:sldLayoutIdLst>
   <p:txStyles>
     <p:titleStyle>
@@ -3106,7 +3106,7 @@
           <p:nvPr/>
         </p:nvPicPr>
         <p:blipFill>
-          <a:blip xmlns:r="http://schemas.openxmlformats.org/officeDocument/2006/relationships" xmlns:a="http://schemas.openxmlformats.org/drawingml/2006/main" r:embed="R128e7fdac9a04bb4"/>
+          <a:blip xmlns:r="http://schemas.openxmlformats.org/officeDocument/2006/relationships" xmlns:a="http://schemas.openxmlformats.org/drawingml/2006/main" r:embed="R49d244580f1848ac"/>
           <a:stretch xmlns:a="http://schemas.openxmlformats.org/drawingml/2006/main"/>
         </p:blipFill>
         <p:spPr>
@@ -3124,7 +3124,7 @@
           <p:cNvPr id="2" name="TransitOps">
             <a:extLst xmlns:a="http://schemas.openxmlformats.org/drawingml/2006/main">
               <a:ext uri="{FF2B5EF4-FFF2-40B4-BE49-F238E27FC236}">
-                <a16:creationId xmlns:a16="http://schemas.microsoft.com/office/drawing/2014/main" id="{37439AD1-5B16-4438-87C8-0F4BC6A01EBE}"/>
+                <a16:creationId xmlns:a16="http://schemas.microsoft.com/office/drawing/2014/main" id="{EF8138CD-8857-40C3-87AA-AA7D7D3E1B96}"/>
               </a:ext>
             </a:extLst>
           </p:cNvPr>
@@ -3181,7 +3181,7 @@
           <p:cNvPr id="3" name="Diseño y desarrollo de una aplicación&#10;de gestión de transpor">
             <a:extLst xmlns:a="http://schemas.openxmlformats.org/drawingml/2006/main">
               <a:ext uri="{FF2B5EF4-FFF2-40B4-BE49-F238E27FC236}">
-                <a16:creationId xmlns:a16="http://schemas.microsoft.com/office/drawing/2014/main" id="{099F3ECE-1B43-4AAA-8DE0-4EC9D57978B0}"/>
+                <a16:creationId xmlns:a16="http://schemas.microsoft.com/office/drawing/2014/main" id="{BA410656-A81E-457E-9122-8D679433FF07}"/>
               </a:ext>
             </a:extLst>
           </p:cNvPr>
@@ -3261,7 +3261,7 @@
           <p:cNvPr id="4" name="Ciclo de vida completo del software">
             <a:extLst xmlns:a="http://schemas.openxmlformats.org/drawingml/2006/main">
               <a:ext uri="{FF2B5EF4-FFF2-40B4-BE49-F238E27FC236}">
-                <a16:creationId xmlns:a16="http://schemas.microsoft.com/office/drawing/2014/main" id="{DC53E0A2-9D97-475A-9439-76B12C54645E}"/>
+                <a16:creationId xmlns:a16="http://schemas.microsoft.com/office/drawing/2014/main" id="{BBA5ECFA-BCD6-4755-BFAC-C85F48FD5045}"/>
               </a:ext>
             </a:extLst>
           </p:cNvPr>
@@ -3318,7 +3318,7 @@
           <p:cNvPr id="5" name="Pablo Manzanares López">
             <a:extLst xmlns:a="http://schemas.openxmlformats.org/drawingml/2006/main">
               <a:ext uri="{FF2B5EF4-FFF2-40B4-BE49-F238E27FC236}">
-                <a16:creationId xmlns:a16="http://schemas.microsoft.com/office/drawing/2014/main" id="{E2E69F2E-2147-4A55-859E-9B1433322DF5}"/>
+                <a16:creationId xmlns:a16="http://schemas.microsoft.com/office/drawing/2014/main" id="{37E44746-146D-4E79-92EB-906E63F10568}"/>
               </a:ext>
             </a:extLst>
           </p:cNvPr>
@@ -3375,7 +3375,7 @@
           <p:cNvPr id="6" name="Dirección: Paula María Castro Castro">
             <a:extLst xmlns:a="http://schemas.openxmlformats.org/drawingml/2006/main">
               <a:ext uri="{FF2B5EF4-FFF2-40B4-BE49-F238E27FC236}">
-                <a16:creationId xmlns:a16="http://schemas.microsoft.com/office/drawing/2014/main" id="{DD0E8769-AA6D-4B43-B7C8-08B070B47779}"/>
+                <a16:creationId xmlns:a16="http://schemas.microsoft.com/office/drawing/2014/main" id="{3B49839C-BB84-49E2-BE1B-51E4D803644D}"/>
               </a:ext>
             </a:extLst>
           </p:cNvPr>
@@ -3432,7 +3432,7 @@
           <p:cNvPr id="7" name="Grado en Ingeniería Informática&#10;Mención en Ingeniería del So">
             <a:extLst xmlns:a="http://schemas.openxmlformats.org/drawingml/2006/main">
               <a:ext uri="{FF2B5EF4-FFF2-40B4-BE49-F238E27FC236}">
-                <a16:creationId xmlns:a16="http://schemas.microsoft.com/office/drawing/2014/main" id="{FB62C7ED-7BDC-4372-A457-5F77BBE9CB6F}"/>
+                <a16:creationId xmlns:a16="http://schemas.microsoft.com/office/drawing/2014/main" id="{CC791055-8212-4D75-94D8-B9C2AF87AC04}"/>
               </a:ext>
             </a:extLst>
           </p:cNvPr>
@@ -3512,7 +3512,7 @@
           <p:cNvPr id="8" name="Facultad de Informática · Septiembre de 2026">
             <a:extLst xmlns:a="http://schemas.openxmlformats.org/drawingml/2006/main">
               <a:ext uri="{FF2B5EF4-FFF2-40B4-BE49-F238E27FC236}">
-                <a16:creationId xmlns:a16="http://schemas.microsoft.com/office/drawing/2014/main" id="{DB747C5A-7105-4DF2-A73A-18854A83B1C7}"/>
+                <a16:creationId xmlns:a16="http://schemas.microsoft.com/office/drawing/2014/main" id="{BC7E4345-59C3-4D10-9A4E-E3FAFC173F5E}"/>
               </a:ext>
             </a:extLst>
           </p:cNvPr>
@@ -3567,7 +3567,7 @@
     </p:spTree>
     <p:extLst>
       <p:ext uri="{BB962C8B-B14F-4D97-AF65-F5344CB8AC3E}">
-        <p14:creationId xmlns:p14="http://schemas.microsoft.com/office/powerpoint/2010/main" val="1013050162"/>
+        <p14:creationId xmlns:p14="http://schemas.microsoft.com/office/powerpoint/2010/main" val="1702855827"/>
       </p:ext>
     </p:extLst>
   </p:cSld>
@@ -3598,7 +3598,7 @@
           <p:cNvPr id="17" name="05 · DEMOSTRACIÓN FUNCIONAL">
             <a:extLst xmlns:a="http://schemas.openxmlformats.org/drawingml/2006/main">
               <a:ext uri="{FF2B5EF4-FFF2-40B4-BE49-F238E27FC236}">
-                <a16:creationId xmlns:a16="http://schemas.microsoft.com/office/drawing/2014/main" id="{F0BEE112-5F39-4892-8231-8A37CB7DE313}"/>
+                <a16:creationId xmlns:a16="http://schemas.microsoft.com/office/drawing/2014/main" id="{A0F039C9-F75B-479E-9233-E99A410722FF}"/>
               </a:ext>
             </a:extLst>
           </p:cNvPr>
@@ -3655,7 +3655,7 @@
           <p:cNvPr id="2" name="Flujo operativo completo">
             <a:extLst xmlns:a="http://schemas.openxmlformats.org/drawingml/2006/main">
               <a:ext uri="{FF2B5EF4-FFF2-40B4-BE49-F238E27FC236}">
-                <a16:creationId xmlns:a16="http://schemas.microsoft.com/office/drawing/2014/main" id="{DFF0FD2B-479C-481F-9E83-9200E4CCC068}"/>
+                <a16:creationId xmlns:a16="http://schemas.microsoft.com/office/drawing/2014/main" id="{DA1FE0F0-3A53-49BA-89E7-51368559BA36}"/>
               </a:ext>
             </a:extLst>
           </p:cNvPr>
@@ -3712,7 +3712,7 @@
           <p:cNvPr id="3" name="">
             <a:extLst xmlns:a="http://schemas.openxmlformats.org/drawingml/2006/main">
               <a:ext uri="{FF2B5EF4-FFF2-40B4-BE49-F238E27FC236}">
-                <a16:creationId xmlns:a16="http://schemas.microsoft.com/office/drawing/2014/main" id="{E63F91D3-15EF-49F0-8C09-396B3C2BDE4E}"/>
+                <a16:creationId xmlns:a16="http://schemas.microsoft.com/office/drawing/2014/main" id="{3EF0C3E2-755E-4E5E-93B9-0EA1F8FDF1D4}"/>
               </a:ext>
             </a:extLst>
           </p:cNvPr>
@@ -3742,7 +3742,7 @@
           <p:cNvPr id="4" name="10">
             <a:extLst xmlns:a="http://schemas.openxmlformats.org/drawingml/2006/main">
               <a:ext uri="{FF2B5EF4-FFF2-40B4-BE49-F238E27FC236}">
-                <a16:creationId xmlns:a16="http://schemas.microsoft.com/office/drawing/2014/main" id="{CB0B182E-942D-4B48-B503-407D72F23966}"/>
+                <a16:creationId xmlns:a16="http://schemas.microsoft.com/office/drawing/2014/main" id="{052E9028-D21B-4338-9AF5-A906B39E43FD}"/>
               </a:ext>
             </a:extLst>
           </p:cNvPr>
@@ -3803,7 +3803,7 @@
           <p:nvPr/>
         </p:nvPicPr>
         <p:blipFill>
-          <a:blip xmlns:r="http://schemas.openxmlformats.org/officeDocument/2006/relationships" xmlns:a="http://schemas.openxmlformats.org/drawingml/2006/main" r:embed="R2c571ac36a114d2b"/>
+          <a:blip xmlns:r="http://schemas.openxmlformats.org/officeDocument/2006/relationships" xmlns:a="http://schemas.openxmlformats.org/drawingml/2006/main" r:embed="Rfedd0e1ac5414a9d"/>
           <a:stretch xmlns:a="http://schemas.openxmlformats.org/drawingml/2006/main"/>
         </p:blipFill>
         <p:spPr>
@@ -3821,7 +3821,7 @@
           <p:cNvPr id="6" name="1">
             <a:extLst xmlns:a="http://schemas.openxmlformats.org/drawingml/2006/main">
               <a:ext uri="{FF2B5EF4-FFF2-40B4-BE49-F238E27FC236}">
-                <a16:creationId xmlns:a16="http://schemas.microsoft.com/office/drawing/2014/main" id="{3C83DB89-39E1-4E00-9FB6-C92C50C3BD32}"/>
+                <a16:creationId xmlns:a16="http://schemas.microsoft.com/office/drawing/2014/main" id="{3829D43E-9570-4D87-9441-2AF649E2B0F3}"/>
               </a:ext>
             </a:extLst>
           </p:cNvPr>
@@ -3878,7 +3878,7 @@
           <p:cNvPr id="7" name="Preparar catálogos">
             <a:extLst xmlns:a="http://schemas.openxmlformats.org/drawingml/2006/main">
               <a:ext uri="{FF2B5EF4-FFF2-40B4-BE49-F238E27FC236}">
-                <a16:creationId xmlns:a16="http://schemas.microsoft.com/office/drawing/2014/main" id="{A29F85E3-503A-48E6-A999-6DAA9413885B}"/>
+                <a16:creationId xmlns:a16="http://schemas.microsoft.com/office/drawing/2014/main" id="{3C640FBC-9F9D-4F35-AB70-2DD9ADD4EF85}"/>
               </a:ext>
             </a:extLst>
           </p:cNvPr>
@@ -3935,7 +3935,7 @@
           <p:cNvPr id="8" name="2">
             <a:extLst xmlns:a="http://schemas.openxmlformats.org/drawingml/2006/main">
               <a:ext uri="{FF2B5EF4-FFF2-40B4-BE49-F238E27FC236}">
-                <a16:creationId xmlns:a16="http://schemas.microsoft.com/office/drawing/2014/main" id="{2B7FFD2C-2615-4C1B-88C7-68C4B4B1581F}"/>
+                <a16:creationId xmlns:a16="http://schemas.microsoft.com/office/drawing/2014/main" id="{9D118272-8755-458C-A41A-0C402161F492}"/>
               </a:ext>
             </a:extLst>
           </p:cNvPr>
@@ -3992,7 +3992,7 @@
           <p:cNvPr id="9" name="Crear el envío">
             <a:extLst xmlns:a="http://schemas.openxmlformats.org/drawingml/2006/main">
               <a:ext uri="{FF2B5EF4-FFF2-40B4-BE49-F238E27FC236}">
-                <a16:creationId xmlns:a16="http://schemas.microsoft.com/office/drawing/2014/main" id="{86C73980-DA2E-4621-B261-C9915A5ED117}"/>
+                <a16:creationId xmlns:a16="http://schemas.microsoft.com/office/drawing/2014/main" id="{123B2439-25E9-4019-A3C6-3F34B23213FD}"/>
               </a:ext>
             </a:extLst>
           </p:cNvPr>
@@ -4049,7 +4049,7 @@
           <p:cNvPr id="10" name="3">
             <a:extLst xmlns:a="http://schemas.openxmlformats.org/drawingml/2006/main">
               <a:ext uri="{FF2B5EF4-FFF2-40B4-BE49-F238E27FC236}">
-                <a16:creationId xmlns:a16="http://schemas.microsoft.com/office/drawing/2014/main" id="{E3403FDE-2E46-4FB4-BA69-ADC5669400ED}"/>
+                <a16:creationId xmlns:a16="http://schemas.microsoft.com/office/drawing/2014/main" id="{20C8AD92-E7CF-428B-99FF-709E446FA2F3}"/>
               </a:ext>
             </a:extLst>
           </p:cNvPr>
@@ -4106,7 +4106,7 @@
           <p:cNvPr id="11" name="Asignar recursos">
             <a:extLst xmlns:a="http://schemas.openxmlformats.org/drawingml/2006/main">
               <a:ext uri="{FF2B5EF4-FFF2-40B4-BE49-F238E27FC236}">
-                <a16:creationId xmlns:a16="http://schemas.microsoft.com/office/drawing/2014/main" id="{7123BA4E-3A98-41DC-920D-7CF9E9D3EB2D}"/>
+                <a16:creationId xmlns:a16="http://schemas.microsoft.com/office/drawing/2014/main" id="{4B9C32FF-2D03-4A67-A8CD-AE778A885EBB}"/>
               </a:ext>
             </a:extLst>
           </p:cNvPr>
@@ -4163,7 +4163,7 @@
           <p:cNvPr id="12" name="4">
             <a:extLst xmlns:a="http://schemas.openxmlformats.org/drawingml/2006/main">
               <a:ext uri="{FF2B5EF4-FFF2-40B4-BE49-F238E27FC236}">
-                <a16:creationId xmlns:a16="http://schemas.microsoft.com/office/drawing/2014/main" id="{579262CC-5C31-428E-AE3B-C892E42736F6}"/>
+                <a16:creationId xmlns:a16="http://schemas.microsoft.com/office/drawing/2014/main" id="{74A4764C-06B7-473E-981C-1D972173B891}"/>
               </a:ext>
             </a:extLst>
           </p:cNvPr>
@@ -4220,7 +4220,7 @@
           <p:cNvPr id="13" name="Registrar el trayecto">
             <a:extLst xmlns:a="http://schemas.openxmlformats.org/drawingml/2006/main">
               <a:ext uri="{FF2B5EF4-FFF2-40B4-BE49-F238E27FC236}">
-                <a16:creationId xmlns:a16="http://schemas.microsoft.com/office/drawing/2014/main" id="{1FA2CDCF-D1C4-4AF1-903E-3D32B4611052}"/>
+                <a16:creationId xmlns:a16="http://schemas.microsoft.com/office/drawing/2014/main" id="{E6CE1ED4-D0FB-443A-B861-8B817201A109}"/>
               </a:ext>
             </a:extLst>
           </p:cNvPr>
@@ -4277,7 +4277,7 @@
           <p:cNvPr id="14" name="5">
             <a:extLst xmlns:a="http://schemas.openxmlformats.org/drawingml/2006/main">
               <a:ext uri="{FF2B5EF4-FFF2-40B4-BE49-F238E27FC236}">
-                <a16:creationId xmlns:a16="http://schemas.microsoft.com/office/drawing/2014/main" id="{4D0A09F2-D2F3-4012-81A5-125265853BF7}"/>
+                <a16:creationId xmlns:a16="http://schemas.microsoft.com/office/drawing/2014/main" id="{5179E403-23CB-4C60-B3AC-D7480E479467}"/>
               </a:ext>
             </a:extLst>
           </p:cNvPr>
@@ -4334,7 +4334,7 @@
           <p:cNvPr id="15" name="Cerrar y resumir">
             <a:extLst xmlns:a="http://schemas.openxmlformats.org/drawingml/2006/main">
               <a:ext uri="{FF2B5EF4-FFF2-40B4-BE49-F238E27FC236}">
-                <a16:creationId xmlns:a16="http://schemas.microsoft.com/office/drawing/2014/main" id="{EF15AC13-20DE-454A-B264-6EE5C49DADB5}"/>
+                <a16:creationId xmlns:a16="http://schemas.microsoft.com/office/drawing/2014/main" id="{584D34BA-46BF-42BD-8288-941C1EFC4A80}"/>
               </a:ext>
             </a:extLst>
           </p:cNvPr>
@@ -4391,7 +4391,7 @@
           <p:cNvPr id="16" name="El flujo reúne los casos de uso 2 y 3. Estado terminal tras ">
             <a:extLst xmlns:a="http://schemas.openxmlformats.org/drawingml/2006/main">
               <a:ext uri="{FF2B5EF4-FFF2-40B4-BE49-F238E27FC236}">
-                <a16:creationId xmlns:a16="http://schemas.microsoft.com/office/drawing/2014/main" id="{E62F4B96-659A-4369-ABA0-D0FAC1C22866}"/>
+                <a16:creationId xmlns:a16="http://schemas.microsoft.com/office/drawing/2014/main" id="{B7622084-04C3-47D0-900D-F2CF0DC295F4}"/>
               </a:ext>
             </a:extLst>
           </p:cNvPr>
@@ -4446,7 +4446,7 @@
     </p:spTree>
     <p:extLst>
       <p:ext uri="{BB962C8B-B14F-4D97-AF65-F5344CB8AC3E}">
-        <p14:creationId xmlns:p14="http://schemas.microsoft.com/office/powerpoint/2010/main" val="361768884"/>
+        <p14:creationId xmlns:p14="http://schemas.microsoft.com/office/powerpoint/2010/main" val="19791910"/>
       </p:ext>
     </p:extLst>
   </p:cSld>
@@ -4477,7 +4477,7 @@
           <p:cNvPr id="12" name="05 · DEMOSTRACIÓN FUNCIONAL">
             <a:extLst xmlns:a="http://schemas.openxmlformats.org/drawingml/2006/main">
               <a:ext uri="{FF2B5EF4-FFF2-40B4-BE49-F238E27FC236}">
-                <a16:creationId xmlns:a16="http://schemas.microsoft.com/office/drawing/2014/main" id="{CA391DF0-0CFE-4274-9AD3-17651C0B9F86}"/>
+                <a16:creationId xmlns:a16="http://schemas.microsoft.com/office/drawing/2014/main" id="{8B3467F8-B9E0-4D7A-8A40-0CE8DAEBF49F}"/>
               </a:ext>
             </a:extLst>
           </p:cNvPr>
@@ -4534,7 +4534,7 @@
           <p:cNvPr id="2" name="Planificación y asignación">
             <a:extLst xmlns:a="http://schemas.openxmlformats.org/drawingml/2006/main">
               <a:ext uri="{FF2B5EF4-FFF2-40B4-BE49-F238E27FC236}">
-                <a16:creationId xmlns:a16="http://schemas.microsoft.com/office/drawing/2014/main" id="{25FCD8EF-3D31-47F1-A6BE-65932D421CD8}"/>
+                <a16:creationId xmlns:a16="http://schemas.microsoft.com/office/drawing/2014/main" id="{38749A7F-E50E-416D-A012-269A7E5F502C}"/>
               </a:ext>
             </a:extLst>
           </p:cNvPr>
@@ -4591,7 +4591,7 @@
           <p:cNvPr id="3" name="">
             <a:extLst xmlns:a="http://schemas.openxmlformats.org/drawingml/2006/main">
               <a:ext uri="{FF2B5EF4-FFF2-40B4-BE49-F238E27FC236}">
-                <a16:creationId xmlns:a16="http://schemas.microsoft.com/office/drawing/2014/main" id="{4D36F532-FE8A-4FDE-8257-E70435F70C7B}"/>
+                <a16:creationId xmlns:a16="http://schemas.microsoft.com/office/drawing/2014/main" id="{C7799AD3-99FF-4384-B9E8-3E2C6826C424}"/>
               </a:ext>
             </a:extLst>
           </p:cNvPr>
@@ -4621,7 +4621,7 @@
           <p:cNvPr id="4" name="11">
             <a:extLst xmlns:a="http://schemas.openxmlformats.org/drawingml/2006/main">
               <a:ext uri="{FF2B5EF4-FFF2-40B4-BE49-F238E27FC236}">
-                <a16:creationId xmlns:a16="http://schemas.microsoft.com/office/drawing/2014/main" id="{B2040240-32AE-4437-8F5B-96C30AC2C4C6}"/>
+                <a16:creationId xmlns:a16="http://schemas.microsoft.com/office/drawing/2014/main" id="{BE454CC7-F23C-49D9-8213-27A9B78A64EA}"/>
               </a:ext>
             </a:extLst>
           </p:cNvPr>
@@ -4682,7 +4682,7 @@
           <p:nvPr/>
         </p:nvPicPr>
         <p:blipFill>
-          <a:blip xmlns:r="http://schemas.openxmlformats.org/officeDocument/2006/relationships" xmlns:a="http://schemas.openxmlformats.org/drawingml/2006/main" r:embed="Rd014c4ca455c4538"/>
+          <a:blip xmlns:r="http://schemas.openxmlformats.org/officeDocument/2006/relationships" xmlns:a="http://schemas.openxmlformats.org/drawingml/2006/main" r:embed="R732e84843d494139"/>
           <a:srcRect xmlns:a="http://schemas.openxmlformats.org/drawingml/2006/main" l="5534" t="23174" r="6719" b="5478"/>
           <a:stretch xmlns:a="http://schemas.openxmlformats.org/drawingml/2006/main">
             <a:fillRect l="0" t="0" r="0" b="0"/>
@@ -4703,7 +4703,7 @@
           <p:cNvPr id="6" name="Asignación conjunta">
             <a:extLst xmlns:a="http://schemas.openxmlformats.org/drawingml/2006/main">
               <a:ext uri="{FF2B5EF4-FFF2-40B4-BE49-F238E27FC236}">
-                <a16:creationId xmlns:a16="http://schemas.microsoft.com/office/drawing/2014/main" id="{D8137382-9A7D-4508-9B48-790428035559}"/>
+                <a16:creationId xmlns:a16="http://schemas.microsoft.com/office/drawing/2014/main" id="{E1A1910D-828E-4858-AFF0-34E0EE3BA3B2}"/>
               </a:ext>
             </a:extLst>
           </p:cNvPr>
@@ -4760,7 +4760,7 @@
           <p:cNvPr id="7" name="Vehículo y conductor solo mientras el envío está planificado">
             <a:extLst xmlns:a="http://schemas.openxmlformats.org/drawingml/2006/main">
               <a:ext uri="{FF2B5EF4-FFF2-40B4-BE49-F238E27FC236}">
-                <a16:creationId xmlns:a16="http://schemas.microsoft.com/office/drawing/2014/main" id="{2B7024C3-3195-424D-8D01-6AE25C9128BA}"/>
+                <a16:creationId xmlns:a16="http://schemas.microsoft.com/office/drawing/2014/main" id="{C5E64978-7D38-4BEB-83CF-E07F13ED51A3}"/>
               </a:ext>
             </a:extLst>
           </p:cNvPr>
@@ -4817,7 +4817,7 @@
           <p:cNvPr id="8" name="Dos respuestas">
             <a:extLst xmlns:a="http://schemas.openxmlformats.org/drawingml/2006/main">
               <a:ext uri="{FF2B5EF4-FFF2-40B4-BE49-F238E27FC236}">
-                <a16:creationId xmlns:a16="http://schemas.microsoft.com/office/drawing/2014/main" id="{62322CFC-963B-4009-B55F-CFFA8C5A5EC6}"/>
+                <a16:creationId xmlns:a16="http://schemas.microsoft.com/office/drawing/2014/main" id="{9C2E7FBD-D7CA-4ACB-AA60-B0337D1C3528}"/>
               </a:ext>
             </a:extLst>
           </p:cNvPr>
@@ -4874,7 +4874,7 @@
           <p:cNvPr id="9" name="Recurso ocupado: bloqueo&#10;Capacidad insuficiente: aviso">
             <a:extLst xmlns:a="http://schemas.openxmlformats.org/drawingml/2006/main">
               <a:ext uri="{FF2B5EF4-FFF2-40B4-BE49-F238E27FC236}">
-                <a16:creationId xmlns:a16="http://schemas.microsoft.com/office/drawing/2014/main" id="{193AEB5D-DB57-4CD3-8D66-7622CB144C6C}"/>
+                <a16:creationId xmlns:a16="http://schemas.microsoft.com/office/drawing/2014/main" id="{8C2B236E-FA61-44C2-B112-CF1255E75B88}"/>
               </a:ext>
             </a:extLst>
           </p:cNvPr>
@@ -4954,7 +4954,7 @@
           <p:cNvPr id="10" name="4.500 kg sobre 3.000 kg">
             <a:extLst xmlns:a="http://schemas.openxmlformats.org/drawingml/2006/main">
               <a:ext uri="{FF2B5EF4-FFF2-40B4-BE49-F238E27FC236}">
-                <a16:creationId xmlns:a16="http://schemas.microsoft.com/office/drawing/2014/main" id="{B26AD1D6-79EA-4DAA-9203-BCB0DB6526DE}"/>
+                <a16:creationId xmlns:a16="http://schemas.microsoft.com/office/drawing/2014/main" id="{C6715EAA-B198-4E64-8EDD-D1E1BCFA4484}"/>
               </a:ext>
             </a:extLst>
           </p:cNvPr>
@@ -5011,7 +5011,7 @@
           <p:cNvPr id="11" name="Captura con datos de prueba del Sprint 4. Figura 7.5 de la m">
             <a:extLst xmlns:a="http://schemas.openxmlformats.org/drawingml/2006/main">
               <a:ext uri="{FF2B5EF4-FFF2-40B4-BE49-F238E27FC236}">
-                <a16:creationId xmlns:a16="http://schemas.microsoft.com/office/drawing/2014/main" id="{381EB51B-A0AC-4EB8-A018-0047F1DE7311}"/>
+                <a16:creationId xmlns:a16="http://schemas.microsoft.com/office/drawing/2014/main" id="{D6164C98-FFB4-483E-8AB6-E49D573F14B0}"/>
               </a:ext>
             </a:extLst>
           </p:cNvPr>
@@ -5066,7 +5066,7 @@
     </p:spTree>
     <p:extLst>
       <p:ext uri="{BB962C8B-B14F-4D97-AF65-F5344CB8AC3E}">
-        <p14:creationId xmlns:p14="http://schemas.microsoft.com/office/powerpoint/2010/main" val="809934451"/>
+        <p14:creationId xmlns:p14="http://schemas.microsoft.com/office/powerpoint/2010/main" val="1993755234"/>
       </p:ext>
     </p:extLst>
   </p:cSld>
@@ -5097,7 +5097,7 @@
           <p:cNvPr id="13" name="05 · DEMOSTRACIÓN FUNCIONAL">
             <a:extLst xmlns:a="http://schemas.openxmlformats.org/drawingml/2006/main">
               <a:ext uri="{FF2B5EF4-FFF2-40B4-BE49-F238E27FC236}">
-                <a16:creationId xmlns:a16="http://schemas.microsoft.com/office/drawing/2014/main" id="{8D68D48B-639C-473F-8B6F-79E8D3BDC8B9}"/>
+                <a16:creationId xmlns:a16="http://schemas.microsoft.com/office/drawing/2014/main" id="{463EE900-3A15-453A-9B23-4DE35E460AC9}"/>
               </a:ext>
             </a:extLst>
           </p:cNvPr>
@@ -5154,7 +5154,7 @@
           <p:cNvPr id="2" name="Ejecución y trazabilidad">
             <a:extLst xmlns:a="http://schemas.openxmlformats.org/drawingml/2006/main">
               <a:ext uri="{FF2B5EF4-FFF2-40B4-BE49-F238E27FC236}">
-                <a16:creationId xmlns:a16="http://schemas.microsoft.com/office/drawing/2014/main" id="{28866416-D219-41AE-8862-B273546AB7C9}"/>
+                <a16:creationId xmlns:a16="http://schemas.microsoft.com/office/drawing/2014/main" id="{039D67F0-BBAC-4F5A-9E4F-C6098B731D5C}"/>
               </a:ext>
             </a:extLst>
           </p:cNvPr>
@@ -5211,7 +5211,7 @@
           <p:cNvPr id="3" name="">
             <a:extLst xmlns:a="http://schemas.openxmlformats.org/drawingml/2006/main">
               <a:ext uri="{FF2B5EF4-FFF2-40B4-BE49-F238E27FC236}">
-                <a16:creationId xmlns:a16="http://schemas.microsoft.com/office/drawing/2014/main" id="{66D211AB-6C08-433B-9793-FABE5034FF11}"/>
+                <a16:creationId xmlns:a16="http://schemas.microsoft.com/office/drawing/2014/main" id="{EFAF23FC-AEE4-4FA5-A936-95A8FE0394A5}"/>
               </a:ext>
             </a:extLst>
           </p:cNvPr>
@@ -5241,7 +5241,7 @@
           <p:cNvPr id="4" name="12">
             <a:extLst xmlns:a="http://schemas.openxmlformats.org/drawingml/2006/main">
               <a:ext uri="{FF2B5EF4-FFF2-40B4-BE49-F238E27FC236}">
-                <a16:creationId xmlns:a16="http://schemas.microsoft.com/office/drawing/2014/main" id="{E58FAD26-5EE1-40D1-8DD3-58F1EB530181}"/>
+                <a16:creationId xmlns:a16="http://schemas.microsoft.com/office/drawing/2014/main" id="{FB6C6C89-1214-497C-BCFE-040E550BE16A}"/>
               </a:ext>
             </a:extLst>
           </p:cNvPr>
@@ -5302,7 +5302,7 @@
           <p:nvPr/>
         </p:nvPicPr>
         <p:blipFill>
-          <a:blip xmlns:r="http://schemas.openxmlformats.org/officeDocument/2006/relationships" xmlns:a="http://schemas.openxmlformats.org/drawingml/2006/main" r:embed="Rc2e62ff644ce4e0d"/>
+          <a:blip xmlns:r="http://schemas.openxmlformats.org/officeDocument/2006/relationships" xmlns:a="http://schemas.openxmlformats.org/drawingml/2006/main" r:embed="Re9bf21264d8f47ca"/>
           <a:srcRect xmlns:a="http://schemas.openxmlformats.org/drawingml/2006/main" l="6719" t="21910" r="27510" b="8708"/>
           <a:stretch xmlns:a="http://schemas.openxmlformats.org/drawingml/2006/main">
             <a:fillRect l="0" t="0" r="0" b="0"/>
@@ -5323,7 +5323,7 @@
           <p:cNvPr id="6" name="Cronología verificable">
             <a:extLst xmlns:a="http://schemas.openxmlformats.org/drawingml/2006/main">
               <a:ext uri="{FF2B5EF4-FFF2-40B4-BE49-F238E27FC236}">
-                <a16:creationId xmlns:a16="http://schemas.microsoft.com/office/drawing/2014/main" id="{1F6876B0-0725-4E69-9B17-355E1203BDEC}"/>
+                <a16:creationId xmlns:a16="http://schemas.microsoft.com/office/drawing/2014/main" id="{43826805-7764-4F5E-B81C-19CC0E063F39}"/>
               </a:ext>
             </a:extLst>
           </p:cNvPr>
@@ -5380,7 +5380,7 @@
           <p:cNvPr id="7" name="Eventos automáticos y manuales ordenados por ocurrencia.">
             <a:extLst xmlns:a="http://schemas.openxmlformats.org/drawingml/2006/main">
               <a:ext uri="{FF2B5EF4-FFF2-40B4-BE49-F238E27FC236}">
-                <a16:creationId xmlns:a16="http://schemas.microsoft.com/office/drawing/2014/main" id="{3D48C333-3682-4E21-8A8C-19519BB82DDA}"/>
+                <a16:creationId xmlns:a16="http://schemas.microsoft.com/office/drawing/2014/main" id="{4B90585D-25D6-4B75-B944-314712473281}"/>
               </a:ext>
             </a:extLst>
           </p:cNvPr>
@@ -5437,7 +5437,7 @@
           <p:cNvPr id="8" name="Autoría">
             <a:extLst xmlns:a="http://schemas.openxmlformats.org/drawingml/2006/main">
               <a:ext uri="{FF2B5EF4-FFF2-40B4-BE49-F238E27FC236}">
-                <a16:creationId xmlns:a16="http://schemas.microsoft.com/office/drawing/2014/main" id="{74598F17-48CB-4132-9F23-BE432227951B}"/>
+                <a16:creationId xmlns:a16="http://schemas.microsoft.com/office/drawing/2014/main" id="{2161533A-6EF2-4828-88F5-7999DC08D724}"/>
               </a:ext>
             </a:extLst>
           </p:cNvPr>
@@ -5494,7 +5494,7 @@
           <p:cNvPr id="9" name="El usuario procede de la sesión, no de un dato libre del cli">
             <a:extLst xmlns:a="http://schemas.openxmlformats.org/drawingml/2006/main">
               <a:ext uri="{FF2B5EF4-FFF2-40B4-BE49-F238E27FC236}">
-                <a16:creationId xmlns:a16="http://schemas.microsoft.com/office/drawing/2014/main" id="{07E63EE6-3FF6-4704-BADD-2B1343C830ED}"/>
+                <a16:creationId xmlns:a16="http://schemas.microsoft.com/office/drawing/2014/main" id="{4DDDA5E3-9827-4E72-A732-5702B405E112}"/>
               </a:ext>
             </a:extLst>
           </p:cNvPr>
@@ -5551,7 +5551,7 @@
           <p:cNvPr id="10" name="Consistencia">
             <a:extLst xmlns:a="http://schemas.openxmlformats.org/drawingml/2006/main">
               <a:ext uri="{FF2B5EF4-FFF2-40B4-BE49-F238E27FC236}">
-                <a16:creationId xmlns:a16="http://schemas.microsoft.com/office/drawing/2014/main" id="{BF0821DD-7DBA-4AB2-AB40-F53D1202D14F}"/>
+                <a16:creationId xmlns:a16="http://schemas.microsoft.com/office/drawing/2014/main" id="{160BA9E6-ECB4-4434-83C4-CB2384C914A5}"/>
               </a:ext>
             </a:extLst>
           </p:cNvPr>
@@ -5608,7 +5608,7 @@
           <p:cNvPr id="11" name="Operación y evento se confirman juntos.">
             <a:extLst xmlns:a="http://schemas.openxmlformats.org/drawingml/2006/main">
               <a:ext uri="{FF2B5EF4-FFF2-40B4-BE49-F238E27FC236}">
-                <a16:creationId xmlns:a16="http://schemas.microsoft.com/office/drawing/2014/main" id="{D94477DA-EBFA-45BA-8217-C978549B67DC}"/>
+                <a16:creationId xmlns:a16="http://schemas.microsoft.com/office/drawing/2014/main" id="{C182AFA7-BA95-4DD1-BEAA-915CFD251D28}"/>
               </a:ext>
             </a:extLst>
           </p:cNvPr>
@@ -5665,7 +5665,7 @@
           <p:cNvPr id="12" name="Captura con datos de prueba del Sprint 5. Figura 7.8 de la m">
             <a:extLst xmlns:a="http://schemas.openxmlformats.org/drawingml/2006/main">
               <a:ext uri="{FF2B5EF4-FFF2-40B4-BE49-F238E27FC236}">
-                <a16:creationId xmlns:a16="http://schemas.microsoft.com/office/drawing/2014/main" id="{7B80FA37-3397-4B06-A2F0-96CD2C693735}"/>
+                <a16:creationId xmlns:a16="http://schemas.microsoft.com/office/drawing/2014/main" id="{2B5E88FD-85A0-43BE-900A-AF44DE28DB73}"/>
               </a:ext>
             </a:extLst>
           </p:cNvPr>
@@ -5720,7 +5720,7 @@
     </p:spTree>
     <p:extLst>
       <p:ext uri="{BB962C8B-B14F-4D97-AF65-F5344CB8AC3E}">
-        <p14:creationId xmlns:p14="http://schemas.microsoft.com/office/powerpoint/2010/main" val="1192357317"/>
+        <p14:creationId xmlns:p14="http://schemas.microsoft.com/office/powerpoint/2010/main" val="1320544881"/>
       </p:ext>
     </p:extLst>
   </p:cSld>
@@ -5751,7 +5751,7 @@
           <p:cNvPr id="12" name="05 · DEMOSTRACIÓN FUNCIONAL">
             <a:extLst xmlns:a="http://schemas.openxmlformats.org/drawingml/2006/main">
               <a:ext uri="{FF2B5EF4-FFF2-40B4-BE49-F238E27FC236}">
-                <a16:creationId xmlns:a16="http://schemas.microsoft.com/office/drawing/2014/main" id="{533CF8FB-E745-4FB1-831A-D1DBF81A1603}"/>
+                <a16:creationId xmlns:a16="http://schemas.microsoft.com/office/drawing/2014/main" id="{B9BFA65C-FC6D-4BE3-A935-1524394CC948}"/>
               </a:ext>
             </a:extLst>
           </p:cNvPr>
@@ -5808,7 +5808,7 @@
           <p:cNvPr id="2" name="Administración e indicadores">
             <a:extLst xmlns:a="http://schemas.openxmlformats.org/drawingml/2006/main">
               <a:ext uri="{FF2B5EF4-FFF2-40B4-BE49-F238E27FC236}">
-                <a16:creationId xmlns:a16="http://schemas.microsoft.com/office/drawing/2014/main" id="{95AC9FDF-C059-453D-8022-7CE562596CDF}"/>
+                <a16:creationId xmlns:a16="http://schemas.microsoft.com/office/drawing/2014/main" id="{B0412899-E5C2-49D0-A283-AFEB760C7A54}"/>
               </a:ext>
             </a:extLst>
           </p:cNvPr>
@@ -5865,7 +5865,7 @@
           <p:cNvPr id="3" name="">
             <a:extLst xmlns:a="http://schemas.openxmlformats.org/drawingml/2006/main">
               <a:ext uri="{FF2B5EF4-FFF2-40B4-BE49-F238E27FC236}">
-                <a16:creationId xmlns:a16="http://schemas.microsoft.com/office/drawing/2014/main" id="{C2C97F26-9684-430F-A80A-32EBE55D491C}"/>
+                <a16:creationId xmlns:a16="http://schemas.microsoft.com/office/drawing/2014/main" id="{ABBF9B3E-1353-4BA2-84A5-AD4628B18CE0}"/>
               </a:ext>
             </a:extLst>
           </p:cNvPr>
@@ -5895,7 +5895,7 @@
           <p:cNvPr id="4" name="13">
             <a:extLst xmlns:a="http://schemas.openxmlformats.org/drawingml/2006/main">
               <a:ext uri="{FF2B5EF4-FFF2-40B4-BE49-F238E27FC236}">
-                <a16:creationId xmlns:a16="http://schemas.microsoft.com/office/drawing/2014/main" id="{80000B0C-BB75-4630-AF46-6D8B2947B7AA}"/>
+                <a16:creationId xmlns:a16="http://schemas.microsoft.com/office/drawing/2014/main" id="{E1B2E3FE-2849-4834-9018-D187A82016F5}"/>
               </a:ext>
             </a:extLst>
           </p:cNvPr>
@@ -5956,7 +5956,7 @@
           <p:nvPr/>
         </p:nvPicPr>
         <p:blipFill>
-          <a:blip xmlns:r="http://schemas.openxmlformats.org/officeDocument/2006/relationships" xmlns:a="http://schemas.openxmlformats.org/drawingml/2006/main" r:embed="R51e38e36b2a0430b"/>
+          <a:blip xmlns:r="http://schemas.openxmlformats.org/officeDocument/2006/relationships" xmlns:a="http://schemas.openxmlformats.org/drawingml/2006/main" r:embed="Re1849f945ac14263"/>
           <a:srcRect xmlns:a="http://schemas.openxmlformats.org/drawingml/2006/main" l="5538" t="22518" r="5459" b="24667"/>
           <a:stretch xmlns:a="http://schemas.openxmlformats.org/drawingml/2006/main">
             <a:fillRect l="0" t="0" r="0" b="0"/>
@@ -5977,7 +5977,7 @@
           <p:cNvPr id="6" name="Administración">
             <a:extLst xmlns:a="http://schemas.openxmlformats.org/drawingml/2006/main">
               <a:ext uri="{FF2B5EF4-FFF2-40B4-BE49-F238E27FC236}">
-                <a16:creationId xmlns:a16="http://schemas.microsoft.com/office/drawing/2014/main" id="{D31285CD-0B70-4319-B084-A818D87538A1}"/>
+                <a16:creationId xmlns:a16="http://schemas.microsoft.com/office/drawing/2014/main" id="{C075F2A4-9F87-49CE-8297-8064A35C179C}"/>
               </a:ext>
             </a:extLst>
           </p:cNvPr>
@@ -6034,7 +6034,7 @@
           <p:cNvPr id="7" name="Cuentas, roles, activación y recuperación de contraseña.">
             <a:extLst xmlns:a="http://schemas.openxmlformats.org/drawingml/2006/main">
               <a:ext uri="{FF2B5EF4-FFF2-40B4-BE49-F238E27FC236}">
-                <a16:creationId xmlns:a16="http://schemas.microsoft.com/office/drawing/2014/main" id="{996F4999-C419-4F73-8080-ACE0EC7E5238}"/>
+                <a16:creationId xmlns:a16="http://schemas.microsoft.com/office/drawing/2014/main" id="{BEC59DBB-F2E8-4D8E-9F46-0BE0E54F2422}"/>
               </a:ext>
             </a:extLst>
           </p:cNvPr>
@@ -6091,7 +6091,7 @@
           <p:cNvPr id="8" name="Resumen operativo">
             <a:extLst xmlns:a="http://schemas.openxmlformats.org/drawingml/2006/main">
               <a:ext uri="{FF2B5EF4-FFF2-40B4-BE49-F238E27FC236}">
-                <a16:creationId xmlns:a16="http://schemas.microsoft.com/office/drawing/2014/main" id="{90BF3E24-4641-48CE-8459-411E10A94F67}"/>
+                <a16:creationId xmlns:a16="http://schemas.microsoft.com/office/drawing/2014/main" id="{D9679BFD-3176-424B-B5D8-1D6025BF2221}"/>
               </a:ext>
             </a:extLst>
           </p:cNvPr>
@@ -6148,7 +6148,7 @@
           <p:cNvPr id="9" name="Estados globales, actividad por recurso e incidencias por pe">
             <a:extLst xmlns:a="http://schemas.openxmlformats.org/drawingml/2006/main">
               <a:ext uri="{FF2B5EF4-FFF2-40B4-BE49-F238E27FC236}">
-                <a16:creationId xmlns:a16="http://schemas.microsoft.com/office/drawing/2014/main" id="{BBA783F0-FFC4-4A0A-B825-7EC32AC263F4}"/>
+                <a16:creationId xmlns:a16="http://schemas.microsoft.com/office/drawing/2014/main" id="{0F99E223-067A-4AA1-A616-2E71EEC644E1}"/>
               </a:ext>
             </a:extLst>
           </p:cNvPr>
@@ -6205,7 +6205,7 @@
           <p:cNvPr id="10" name="RF-01 a RF-14 integrados">
             <a:extLst xmlns:a="http://schemas.openxmlformats.org/drawingml/2006/main">
               <a:ext uri="{FF2B5EF4-FFF2-40B4-BE49-F238E27FC236}">
-                <a16:creationId xmlns:a16="http://schemas.microsoft.com/office/drawing/2014/main" id="{8DA98D6F-E39C-4003-A4F5-4F5A1E2B1200}"/>
+                <a16:creationId xmlns:a16="http://schemas.microsoft.com/office/drawing/2014/main" id="{A2705D3F-B97D-40EF-9940-08B17AB5E61B}"/>
               </a:ext>
             </a:extLst>
           </p:cNvPr>
@@ -6262,7 +6262,7 @@
           <p:cNvPr id="11" name="Captura con datos de demostración del Sprint 6. Memoria, pp.">
             <a:extLst xmlns:a="http://schemas.openxmlformats.org/drawingml/2006/main">
               <a:ext uri="{FF2B5EF4-FFF2-40B4-BE49-F238E27FC236}">
-                <a16:creationId xmlns:a16="http://schemas.microsoft.com/office/drawing/2014/main" id="{2C519A41-67A7-47C9-8FFF-87EE4FB71794}"/>
+                <a16:creationId xmlns:a16="http://schemas.microsoft.com/office/drawing/2014/main" id="{B20568C5-253F-4263-A43B-0F3FBBECCF65}"/>
               </a:ext>
             </a:extLst>
           </p:cNvPr>
@@ -6317,7 +6317,7 @@
     </p:spTree>
     <p:extLst>
       <p:ext uri="{BB962C8B-B14F-4D97-AF65-F5344CB8AC3E}">
-        <p14:creationId xmlns:p14="http://schemas.microsoft.com/office/powerpoint/2010/main" val="1297929331"/>
+        <p14:creationId xmlns:p14="http://schemas.microsoft.com/office/powerpoint/2010/main" val="1437438426"/>
       </p:ext>
     </p:extLst>
   </p:cSld>
@@ -6348,7 +6348,7 @@
           <p:cNvPr id="13" name="06 · VALIDACIÓN Y DESPLIEGUE">
             <a:extLst xmlns:a="http://schemas.openxmlformats.org/drawingml/2006/main">
               <a:ext uri="{FF2B5EF4-FFF2-40B4-BE49-F238E27FC236}">
-                <a16:creationId xmlns:a16="http://schemas.microsoft.com/office/drawing/2014/main" id="{70D174C0-A6B0-46EE-B705-35F79D924B88}"/>
+                <a16:creationId xmlns:a16="http://schemas.microsoft.com/office/drawing/2014/main" id="{D57A824A-9D59-4F60-96D1-21F9389645D9}"/>
               </a:ext>
             </a:extLst>
           </p:cNvPr>
@@ -6405,7 +6405,7 @@
           <p:cNvPr id="2" name="Estrategia de validación">
             <a:extLst xmlns:a="http://schemas.openxmlformats.org/drawingml/2006/main">
               <a:ext uri="{FF2B5EF4-FFF2-40B4-BE49-F238E27FC236}">
-                <a16:creationId xmlns:a16="http://schemas.microsoft.com/office/drawing/2014/main" id="{D77AC831-6218-4A5A-B064-EA53B9466BED}"/>
+                <a16:creationId xmlns:a16="http://schemas.microsoft.com/office/drawing/2014/main" id="{4F112CD6-29FB-4C60-B4AB-7A5EA3C3C789}"/>
               </a:ext>
             </a:extLst>
           </p:cNvPr>
@@ -6462,7 +6462,7 @@
           <p:cNvPr id="3" name="">
             <a:extLst xmlns:a="http://schemas.openxmlformats.org/drawingml/2006/main">
               <a:ext uri="{FF2B5EF4-FFF2-40B4-BE49-F238E27FC236}">
-                <a16:creationId xmlns:a16="http://schemas.microsoft.com/office/drawing/2014/main" id="{0FF1A736-AED8-4B2B-91BE-F7AB672FBF4A}"/>
+                <a16:creationId xmlns:a16="http://schemas.microsoft.com/office/drawing/2014/main" id="{D8EA4C10-7E70-43B8-99C0-A5208A6CC003}"/>
               </a:ext>
             </a:extLst>
           </p:cNvPr>
@@ -6492,7 +6492,7 @@
           <p:cNvPr id="4" name="14">
             <a:extLst xmlns:a="http://schemas.openxmlformats.org/drawingml/2006/main">
               <a:ext uri="{FF2B5EF4-FFF2-40B4-BE49-F238E27FC236}">
-                <a16:creationId xmlns:a16="http://schemas.microsoft.com/office/drawing/2014/main" id="{FC68CA62-5DC4-44AA-AEAD-29424A20C5E0}"/>
+                <a16:creationId xmlns:a16="http://schemas.microsoft.com/office/drawing/2014/main" id="{71A3534E-24F2-4A72-9A6A-B2DBE47819DC}"/>
               </a:ext>
             </a:extLst>
           </p:cNvPr>
@@ -6549,7 +6549,7 @@
           <p:cNvPr id="5" name="139">
             <a:extLst xmlns:a="http://schemas.openxmlformats.org/drawingml/2006/main">
               <a:ext uri="{FF2B5EF4-FFF2-40B4-BE49-F238E27FC236}">
-                <a16:creationId xmlns:a16="http://schemas.microsoft.com/office/drawing/2014/main" id="{DBF47D8C-BCF7-4CEE-8CBA-A5BBCF2787A9}"/>
+                <a16:creationId xmlns:a16="http://schemas.microsoft.com/office/drawing/2014/main" id="{F687B01D-F5CC-49BA-ACD6-35D4EEFAAF5D}"/>
               </a:ext>
             </a:extLst>
           </p:cNvPr>
@@ -6606,7 +6606,7 @@
           <p:cNvPr id="6" name="pruebas backend&#10;xUnit">
             <a:extLst xmlns:a="http://schemas.openxmlformats.org/drawingml/2006/main">
               <a:ext uri="{FF2B5EF4-FFF2-40B4-BE49-F238E27FC236}">
-                <a16:creationId xmlns:a16="http://schemas.microsoft.com/office/drawing/2014/main" id="{35E653F2-E8F8-45B9-930B-D2AE241EF45B}"/>
+                <a16:creationId xmlns:a16="http://schemas.microsoft.com/office/drawing/2014/main" id="{34746BEB-20B6-4F5B-B5AE-1E2FD864051D}"/>
               </a:ext>
             </a:extLst>
           </p:cNvPr>
@@ -6686,7 +6686,7 @@
           <p:cNvPr id="7" name="33">
             <a:extLst xmlns:a="http://schemas.openxmlformats.org/drawingml/2006/main">
               <a:ext uri="{FF2B5EF4-FFF2-40B4-BE49-F238E27FC236}">
-                <a16:creationId xmlns:a16="http://schemas.microsoft.com/office/drawing/2014/main" id="{6D8876CD-E857-4CAF-B400-ACB4E6768BD1}"/>
+                <a16:creationId xmlns:a16="http://schemas.microsoft.com/office/drawing/2014/main" id="{16C830A2-D24F-4E75-BE86-D599501C93CF}"/>
               </a:ext>
             </a:extLst>
           </p:cNvPr>
@@ -6743,7 +6743,7 @@
           <p:cNvPr id="8" name="pruebas frontend&#10;Vitest + RTL">
             <a:extLst xmlns:a="http://schemas.openxmlformats.org/drawingml/2006/main">
               <a:ext uri="{FF2B5EF4-FFF2-40B4-BE49-F238E27FC236}">
-                <a16:creationId xmlns:a16="http://schemas.microsoft.com/office/drawing/2014/main" id="{D18A388B-04EF-433C-9B86-702C4F661714}"/>
+                <a16:creationId xmlns:a16="http://schemas.microsoft.com/office/drawing/2014/main" id="{728FDBA7-6129-48A8-95B1-478C9CE52D86}"/>
               </a:ext>
             </a:extLst>
           </p:cNvPr>
@@ -6823,7 +6823,7 @@
           <p:cNvPr id="9" name="4">
             <a:extLst xmlns:a="http://schemas.openxmlformats.org/drawingml/2006/main">
               <a:ext uri="{FF2B5EF4-FFF2-40B4-BE49-F238E27FC236}">
-                <a16:creationId xmlns:a16="http://schemas.microsoft.com/office/drawing/2014/main" id="{DA3A25C6-DCD0-46D1-95A4-78C41E00AFB9}"/>
+                <a16:creationId xmlns:a16="http://schemas.microsoft.com/office/drawing/2014/main" id="{B4E65657-0DC3-44E7-8D62-67B5D44A0E62}"/>
               </a:ext>
             </a:extLst>
           </p:cNvPr>
@@ -6880,7 +6880,7 @@
           <p:cNvPr id="10" name="flujos de sistema&#10;Playwright">
             <a:extLst xmlns:a="http://schemas.openxmlformats.org/drawingml/2006/main">
               <a:ext uri="{FF2B5EF4-FFF2-40B4-BE49-F238E27FC236}">
-                <a16:creationId xmlns:a16="http://schemas.microsoft.com/office/drawing/2014/main" id="{42FEA350-DD71-4FFD-9EEF-A604EEECAD54}"/>
+                <a16:creationId xmlns:a16="http://schemas.microsoft.com/office/drawing/2014/main" id="{872E3DEE-282B-4FEF-9499-2C4FACD9C3E4}"/>
               </a:ext>
             </a:extLst>
           </p:cNvPr>
@@ -7252,7 +7252,7 @@
           <p:cNvPr id="12" name="Recuentos al cierre del Sprint 7. Son casos ejecutados, no p">
             <a:extLst xmlns:a="http://schemas.openxmlformats.org/drawingml/2006/main">
               <a:ext uri="{FF2B5EF4-FFF2-40B4-BE49-F238E27FC236}">
-                <a16:creationId xmlns:a16="http://schemas.microsoft.com/office/drawing/2014/main" id="{916D9E87-3339-4C14-B999-F2EC31450CA4}"/>
+                <a16:creationId xmlns:a16="http://schemas.microsoft.com/office/drawing/2014/main" id="{8E937D5A-6916-4149-BAD2-19946CA85ABB}"/>
               </a:ext>
             </a:extLst>
           </p:cNvPr>
@@ -7307,7 +7307,7 @@
     </p:spTree>
     <p:extLst>
       <p:ext uri="{BB962C8B-B14F-4D97-AF65-F5344CB8AC3E}">
-        <p14:creationId xmlns:p14="http://schemas.microsoft.com/office/powerpoint/2010/main" val="1270488451"/>
+        <p14:creationId xmlns:p14="http://schemas.microsoft.com/office/powerpoint/2010/main" val="185417248"/>
       </p:ext>
     </p:extLst>
   </p:cSld>
@@ -7338,7 +7338,7 @@
           <p:cNvPr id="10" name="06 · VALIDACIÓN Y DESPLIEGUE">
             <a:extLst xmlns:a="http://schemas.openxmlformats.org/drawingml/2006/main">
               <a:ext uri="{FF2B5EF4-FFF2-40B4-BE49-F238E27FC236}">
-                <a16:creationId xmlns:a16="http://schemas.microsoft.com/office/drawing/2014/main" id="{E0005BF4-544B-41FA-9644-D1E39A5AAEFF}"/>
+                <a16:creationId xmlns:a16="http://schemas.microsoft.com/office/drawing/2014/main" id="{E76D3D1D-5A50-42D8-B38A-49365F642B53}"/>
               </a:ext>
             </a:extLst>
           </p:cNvPr>
@@ -7395,7 +7395,7 @@
           <p:cNvPr id="2" name="Despliegue reproducible">
             <a:extLst xmlns:a="http://schemas.openxmlformats.org/drawingml/2006/main">
               <a:ext uri="{FF2B5EF4-FFF2-40B4-BE49-F238E27FC236}">
-                <a16:creationId xmlns:a16="http://schemas.microsoft.com/office/drawing/2014/main" id="{95780D87-B052-4869-8FC4-17127FA00BF0}"/>
+                <a16:creationId xmlns:a16="http://schemas.microsoft.com/office/drawing/2014/main" id="{1E5F120B-3E42-49B4-A00F-1708C1357F17}"/>
               </a:ext>
             </a:extLst>
           </p:cNvPr>
@@ -7452,7 +7452,7 @@
           <p:cNvPr id="3" name="">
             <a:extLst xmlns:a="http://schemas.openxmlformats.org/drawingml/2006/main">
               <a:ext uri="{FF2B5EF4-FFF2-40B4-BE49-F238E27FC236}">
-                <a16:creationId xmlns:a16="http://schemas.microsoft.com/office/drawing/2014/main" id="{3CC9AE92-3987-45F2-BBF8-3C207AC58C95}"/>
+                <a16:creationId xmlns:a16="http://schemas.microsoft.com/office/drawing/2014/main" id="{50B714E9-A644-48DF-B571-C677DD9544F3}"/>
               </a:ext>
             </a:extLst>
           </p:cNvPr>
@@ -7482,7 +7482,7 @@
           <p:cNvPr id="4" name="15">
             <a:extLst xmlns:a="http://schemas.openxmlformats.org/drawingml/2006/main">
               <a:ext uri="{FF2B5EF4-FFF2-40B4-BE49-F238E27FC236}">
-                <a16:creationId xmlns:a16="http://schemas.microsoft.com/office/drawing/2014/main" id="{C28EA067-9CB1-417C-9ED0-CC08921DB7F3}"/>
+                <a16:creationId xmlns:a16="http://schemas.microsoft.com/office/drawing/2014/main" id="{4CF8339D-912F-41EA-AED7-8CEC0B37B38E}"/>
               </a:ext>
             </a:extLst>
           </p:cNvPr>
@@ -7777,7 +7777,7 @@
           <p:cNvPr id="6" name="Acceso HTTPS temporal">
             <a:extLst xmlns:a="http://schemas.openxmlformats.org/drawingml/2006/main">
               <a:ext uri="{FF2B5EF4-FFF2-40B4-BE49-F238E27FC236}">
-                <a16:creationId xmlns:a16="http://schemas.microsoft.com/office/drawing/2014/main" id="{D03F6FD5-47E1-4882-8FE8-02F0C305E8A3}"/>
+                <a16:creationId xmlns:a16="http://schemas.microsoft.com/office/drawing/2014/main" id="{7D98A521-1E7F-4BA5-9CC2-B788B1CC4A43}"/>
               </a:ext>
             </a:extLst>
           </p:cNvPr>
@@ -7834,7 +7834,7 @@
           <p:cNvPr id="7" name="Cuatro servicios, sin puertos de contenedores publicados en ">
             <a:extLst xmlns:a="http://schemas.openxmlformats.org/drawingml/2006/main">
               <a:ext uri="{FF2B5EF4-FFF2-40B4-BE49-F238E27FC236}">
-                <a16:creationId xmlns:a16="http://schemas.microsoft.com/office/drawing/2014/main" id="{BEAFBBEE-3E1F-4E9F-9145-6F77A8B39A2A}"/>
+                <a16:creationId xmlns:a16="http://schemas.microsoft.com/office/drawing/2014/main" id="{A2232907-F5BD-45C2-92A5-12CA9E84C40F}"/>
               </a:ext>
             </a:extLst>
           </p:cNvPr>
@@ -7895,7 +7895,7 @@
           <p:nvPr/>
         </p:nvPicPr>
         <p:blipFill>
-          <a:blip xmlns:r="http://schemas.openxmlformats.org/officeDocument/2006/relationships" xmlns:a="http://schemas.openxmlformats.org/drawingml/2006/main" r:embed="R7b289996308a49a9"/>
+          <a:blip xmlns:r="http://schemas.openxmlformats.org/officeDocument/2006/relationships" xmlns:a="http://schemas.openxmlformats.org/drawingml/2006/main" r:embed="Redc1eddf6ccb4dd7"/>
           <a:stretch xmlns:a="http://schemas.openxmlformats.org/drawingml/2006/main"/>
         </p:blipFill>
         <p:spPr>
@@ -7913,7 +7913,7 @@
           <p:cNvPr id="9" name="Entorno de demostración reproducible. El túnel saliente evit">
             <a:extLst xmlns:a="http://schemas.openxmlformats.org/drawingml/2006/main">
               <a:ext uri="{FF2B5EF4-FFF2-40B4-BE49-F238E27FC236}">
-                <a16:creationId xmlns:a16="http://schemas.microsoft.com/office/drawing/2014/main" id="{F735F983-CF0D-43D5-9302-7D3CBAFD62B7}"/>
+                <a16:creationId xmlns:a16="http://schemas.microsoft.com/office/drawing/2014/main" id="{83511AC4-205E-4839-80F0-9108515904ED}"/>
               </a:ext>
             </a:extLst>
           </p:cNvPr>
@@ -7968,7 +7968,7 @@
     </p:spTree>
     <p:extLst>
       <p:ext uri="{BB962C8B-B14F-4D97-AF65-F5344CB8AC3E}">
-        <p14:creationId xmlns:p14="http://schemas.microsoft.com/office/powerpoint/2010/main" val="1738052034"/>
+        <p14:creationId xmlns:p14="http://schemas.microsoft.com/office/powerpoint/2010/main" val="849381591"/>
       </p:ext>
     </p:extLst>
   </p:cSld>
@@ -7999,7 +7999,7 @@
           <p:cNvPr id="8" name="07 · CONCLUSIONES Y TRABAJO FUTURO">
             <a:extLst xmlns:a="http://schemas.openxmlformats.org/drawingml/2006/main">
               <a:ext uri="{FF2B5EF4-FFF2-40B4-BE49-F238E27FC236}">
-                <a16:creationId xmlns:a16="http://schemas.microsoft.com/office/drawing/2014/main" id="{7FDA5B3C-B023-498D-AE57-D3F783AACA6A}"/>
+                <a16:creationId xmlns:a16="http://schemas.microsoft.com/office/drawing/2014/main" id="{0D671688-29B2-4C40-B2A9-CFBFA1A6F28D}"/>
               </a:ext>
             </a:extLst>
           </p:cNvPr>
@@ -8056,7 +8056,7 @@
           <p:cNvPr id="2" name="Evaluación del resultado">
             <a:extLst xmlns:a="http://schemas.openxmlformats.org/drawingml/2006/main">
               <a:ext uri="{FF2B5EF4-FFF2-40B4-BE49-F238E27FC236}">
-                <a16:creationId xmlns:a16="http://schemas.microsoft.com/office/drawing/2014/main" id="{59C447E0-7F10-4924-971D-F7780E410A66}"/>
+                <a16:creationId xmlns:a16="http://schemas.microsoft.com/office/drawing/2014/main" id="{B3FC0072-1F3E-4CF2-A133-6D091AB53221}"/>
               </a:ext>
             </a:extLst>
           </p:cNvPr>
@@ -8113,7 +8113,7 @@
           <p:cNvPr id="3" name="">
             <a:extLst xmlns:a="http://schemas.openxmlformats.org/drawingml/2006/main">
               <a:ext uri="{FF2B5EF4-FFF2-40B4-BE49-F238E27FC236}">
-                <a16:creationId xmlns:a16="http://schemas.microsoft.com/office/drawing/2014/main" id="{186DA839-C8CE-4DBF-8116-920D595F0BBE}"/>
+                <a16:creationId xmlns:a16="http://schemas.microsoft.com/office/drawing/2014/main" id="{4FFABE85-5A48-4D25-BB13-296473F5DEE8}"/>
               </a:ext>
             </a:extLst>
           </p:cNvPr>
@@ -8143,7 +8143,7 @@
           <p:cNvPr id="4" name="16">
             <a:extLst xmlns:a="http://schemas.openxmlformats.org/drawingml/2006/main">
               <a:ext uri="{FF2B5EF4-FFF2-40B4-BE49-F238E27FC236}">
-                <a16:creationId xmlns:a16="http://schemas.microsoft.com/office/drawing/2014/main" id="{C9A39E15-179B-4A47-A9ED-C127D93F2888}"/>
+                <a16:creationId xmlns:a16="http://schemas.microsoft.com/office/drawing/2014/main" id="{DAEBA585-7BDD-4063-8DE6-032C23E912EB}"/>
               </a:ext>
             </a:extLst>
           </p:cNvPr>
@@ -8623,7 +8623,7 @@
           <p:cNvPr id="6" name="El resultado cumple los criterios técnicos definidos al inic">
             <a:extLst xmlns:a="http://schemas.openxmlformats.org/drawingml/2006/main">
               <a:ext uri="{FF2B5EF4-FFF2-40B4-BE49-F238E27FC236}">
-                <a16:creationId xmlns:a16="http://schemas.microsoft.com/office/drawing/2014/main" id="{A9E6118C-5C95-40AF-9527-0B5B828D8675}"/>
+                <a16:creationId xmlns:a16="http://schemas.microsoft.com/office/drawing/2014/main" id="{2D6B0472-5C6D-42DF-B471-16A3CFD50325}"/>
               </a:ext>
             </a:extLst>
           </p:cNvPr>
@@ -8680,7 +8680,7 @@
           <p:cNvPr id="7" name="Evaluación basada en la trazabilidad, los resultados y las c">
             <a:extLst xmlns:a="http://schemas.openxmlformats.org/drawingml/2006/main">
               <a:ext uri="{FF2B5EF4-FFF2-40B4-BE49-F238E27FC236}">
-                <a16:creationId xmlns:a16="http://schemas.microsoft.com/office/drawing/2014/main" id="{71C9C2F3-07AA-4C55-A298-D19E41992957}"/>
+                <a16:creationId xmlns:a16="http://schemas.microsoft.com/office/drawing/2014/main" id="{9A3E61DE-F883-4261-918F-762A7AFE30B0}"/>
               </a:ext>
             </a:extLst>
           </p:cNvPr>
@@ -8735,7 +8735,7 @@
     </p:spTree>
     <p:extLst>
       <p:ext uri="{BB962C8B-B14F-4D97-AF65-F5344CB8AC3E}">
-        <p14:creationId xmlns:p14="http://schemas.microsoft.com/office/powerpoint/2010/main" val="1279032929"/>
+        <p14:creationId xmlns:p14="http://schemas.microsoft.com/office/powerpoint/2010/main" val="1605769061"/>
       </p:ext>
     </p:extLst>
   </p:cSld>
@@ -8766,7 +8766,7 @@
           <p:cNvPr id="12" name="07 · CONCLUSIONES Y TRABAJO FUTURO">
             <a:extLst xmlns:a="http://schemas.openxmlformats.org/drawingml/2006/main">
               <a:ext uri="{FF2B5EF4-FFF2-40B4-BE49-F238E27FC236}">
-                <a16:creationId xmlns:a16="http://schemas.microsoft.com/office/drawing/2014/main" id="{CC2E445E-CECE-4C92-9EC2-B7C0F85DFFE9}"/>
+                <a16:creationId xmlns:a16="http://schemas.microsoft.com/office/drawing/2014/main" id="{06BCF361-9E4D-47C7-8918-E5420A5D1FF9}"/>
               </a:ext>
             </a:extLst>
           </p:cNvPr>
@@ -8823,7 +8823,7 @@
           <p:cNvPr id="2" name="Límites y trabajo futuro">
             <a:extLst xmlns:a="http://schemas.openxmlformats.org/drawingml/2006/main">
               <a:ext uri="{FF2B5EF4-FFF2-40B4-BE49-F238E27FC236}">
-                <a16:creationId xmlns:a16="http://schemas.microsoft.com/office/drawing/2014/main" id="{B2980BF1-45D1-4F9E-A5BD-F1E0C442A5C5}"/>
+                <a16:creationId xmlns:a16="http://schemas.microsoft.com/office/drawing/2014/main" id="{F8D27384-6802-432B-8CDE-C069C2DE0D89}"/>
               </a:ext>
             </a:extLst>
           </p:cNvPr>
@@ -8880,7 +8880,7 @@
           <p:cNvPr id="3" name="">
             <a:extLst xmlns:a="http://schemas.openxmlformats.org/drawingml/2006/main">
               <a:ext uri="{FF2B5EF4-FFF2-40B4-BE49-F238E27FC236}">
-                <a16:creationId xmlns:a16="http://schemas.microsoft.com/office/drawing/2014/main" id="{19A0F5F1-7E39-4D84-9419-4C4B7AD54E32}"/>
+                <a16:creationId xmlns:a16="http://schemas.microsoft.com/office/drawing/2014/main" id="{9DC38020-F83C-4AB1-9FF3-4152806F1C2F}"/>
               </a:ext>
             </a:extLst>
           </p:cNvPr>
@@ -8910,7 +8910,7 @@
           <p:cNvPr id="4" name="17">
             <a:extLst xmlns:a="http://schemas.openxmlformats.org/drawingml/2006/main">
               <a:ext uri="{FF2B5EF4-FFF2-40B4-BE49-F238E27FC236}">
-                <a16:creationId xmlns:a16="http://schemas.microsoft.com/office/drawing/2014/main" id="{43FD8BFD-5D22-4F79-A8FE-C9628ABC7AD8}"/>
+                <a16:creationId xmlns:a16="http://schemas.microsoft.com/office/drawing/2014/main" id="{B5D9F718-BD93-4D9E-B9D5-CC77C1C729AD}"/>
               </a:ext>
             </a:extLst>
           </p:cNvPr>
@@ -8967,7 +8967,7 @@
           <p:cNvPr id="5" name="Límites del resultado">
             <a:extLst xmlns:a="http://schemas.openxmlformats.org/drawingml/2006/main">
               <a:ext uri="{FF2B5EF4-FFF2-40B4-BE49-F238E27FC236}">
-                <a16:creationId xmlns:a16="http://schemas.microsoft.com/office/drawing/2014/main" id="{22510A9E-6D42-4604-B1BE-B9C2D15F8D7A}"/>
+                <a16:creationId xmlns:a16="http://schemas.microsoft.com/office/drawing/2014/main" id="{B02B3246-A9C2-4C98-97C3-ABA5B074E5AC}"/>
               </a:ext>
             </a:extLst>
           </p:cNvPr>
@@ -9024,7 +9024,7 @@
           <p:cNvPr id="6" name="Caso de negocio simulado&#10;Sin evaluación con usuarios reales&#10;">
             <a:extLst xmlns:a="http://schemas.openxmlformats.org/drawingml/2006/main">
               <a:ext uri="{FF2B5EF4-FFF2-40B4-BE49-F238E27FC236}">
-                <a16:creationId xmlns:a16="http://schemas.microsoft.com/office/drawing/2014/main" id="{BFDD140E-B589-43EC-8EA6-15A0883F9925}"/>
+                <a16:creationId xmlns:a16="http://schemas.microsoft.com/office/drawing/2014/main" id="{1139CF80-A0A9-4112-9326-E01D11298B89}"/>
               </a:ext>
             </a:extLst>
           </p:cNvPr>
@@ -9150,7 +9150,7 @@
           <p:cNvPr id="7" name="Prioridades de continuación">
             <a:extLst xmlns:a="http://schemas.openxmlformats.org/drawingml/2006/main">
               <a:ext uri="{FF2B5EF4-FFF2-40B4-BE49-F238E27FC236}">
-                <a16:creationId xmlns:a16="http://schemas.microsoft.com/office/drawing/2014/main" id="{A99719FD-C85C-46B6-AE30-9CDF4FE33337}"/>
+                <a16:creationId xmlns:a16="http://schemas.microsoft.com/office/drawing/2014/main" id="{8CC96A23-2257-49F8-B95D-E6BF8EE4AA44}"/>
               </a:ext>
             </a:extLst>
           </p:cNvPr>
@@ -9207,7 +9207,7 @@
           <p:cNvPr id="8" name="Validar el núcleo con usuarios&#10;Estabilizar alojamiento y rec">
             <a:extLst xmlns:a="http://schemas.openxmlformats.org/drawingml/2006/main">
               <a:ext uri="{FF2B5EF4-FFF2-40B4-BE49-F238E27FC236}">
-                <a16:creationId xmlns:a16="http://schemas.microsoft.com/office/drawing/2014/main" id="{1279E4F7-84CC-4668-A872-80F22A87B129}"/>
+                <a16:creationId xmlns:a16="http://schemas.microsoft.com/office/drawing/2014/main" id="{96398581-B87D-4FA0-B4BC-7F881545F7E8}"/>
               </a:ext>
             </a:extLst>
           </p:cNvPr>
@@ -9310,7 +9310,7 @@
           <p:cNvPr id="9" name="">
             <a:extLst xmlns:a="http://schemas.openxmlformats.org/drawingml/2006/main">
               <a:ext uri="{FF2B5EF4-FFF2-40B4-BE49-F238E27FC236}">
-                <a16:creationId xmlns:a16="http://schemas.microsoft.com/office/drawing/2014/main" id="{EDF9C451-6C67-40D4-8EE6-19540B642FB8}"/>
+                <a16:creationId xmlns:a16="http://schemas.microsoft.com/office/drawing/2014/main" id="{637238F0-6E32-4413-94AF-844FCBA77865}"/>
               </a:ext>
             </a:extLst>
           </p:cNvPr>
@@ -9340,7 +9340,7 @@
           <p:cNvPr id="10" name="Rutas, GPS, facturación y acceso externo se valorarían despu">
             <a:extLst xmlns:a="http://schemas.openxmlformats.org/drawingml/2006/main">
               <a:ext uri="{FF2B5EF4-FFF2-40B4-BE49-F238E27FC236}">
-                <a16:creationId xmlns:a16="http://schemas.microsoft.com/office/drawing/2014/main" id="{FD9A9C72-9212-45B6-9EAF-7C186F360A32}"/>
+                <a16:creationId xmlns:a16="http://schemas.microsoft.com/office/drawing/2014/main" id="{7E623F9B-5F83-45A5-9AF0-9BFD69B97175}"/>
               </a:ext>
             </a:extLst>
           </p:cNvPr>
@@ -9397,7 +9397,7 @@
           <p:cNvPr id="11" name="Límites y líneas futuras de la memoria, pp. 60 y 66–69.">
             <a:extLst xmlns:a="http://schemas.openxmlformats.org/drawingml/2006/main">
               <a:ext uri="{FF2B5EF4-FFF2-40B4-BE49-F238E27FC236}">
-                <a16:creationId xmlns:a16="http://schemas.microsoft.com/office/drawing/2014/main" id="{1F064674-49FB-45C2-9E41-235950FFE43A}"/>
+                <a16:creationId xmlns:a16="http://schemas.microsoft.com/office/drawing/2014/main" id="{E0AAF625-78CD-464C-8987-46DFFAB59EC9}"/>
               </a:ext>
             </a:extLst>
           </p:cNvPr>
@@ -9452,7 +9452,7 @@
     </p:spTree>
     <p:extLst>
       <p:ext uri="{BB962C8B-B14F-4D97-AF65-F5344CB8AC3E}">
-        <p14:creationId xmlns:p14="http://schemas.microsoft.com/office/powerpoint/2010/main" val="1780725326"/>
+        <p14:creationId xmlns:p14="http://schemas.microsoft.com/office/powerpoint/2010/main" val="1832355847"/>
       </p:ext>
     </p:extLst>
   </p:cSld>
@@ -9483,7 +9483,7 @@
           <p:cNvPr id="10" name="07 · CONCLUSIONES Y TRABAJO FUTURO">
             <a:extLst xmlns:a="http://schemas.openxmlformats.org/drawingml/2006/main">
               <a:ext uri="{FF2B5EF4-FFF2-40B4-BE49-F238E27FC236}">
-                <a16:creationId xmlns:a16="http://schemas.microsoft.com/office/drawing/2014/main" id="{03CCAF61-9EA4-4E9C-8320-4E9E9418B228}"/>
+                <a16:creationId xmlns:a16="http://schemas.microsoft.com/office/drawing/2014/main" id="{C8D5BC2E-1560-4552-9122-56CE76F1E289}"/>
               </a:ext>
             </a:extLst>
           </p:cNvPr>
@@ -9540,7 +9540,7 @@
           <p:cNvPr id="2" name="Conclusiones">
             <a:extLst xmlns:a="http://schemas.openxmlformats.org/drawingml/2006/main">
               <a:ext uri="{FF2B5EF4-FFF2-40B4-BE49-F238E27FC236}">
-                <a16:creationId xmlns:a16="http://schemas.microsoft.com/office/drawing/2014/main" id="{83763D10-6CFE-4708-A577-E9F2E2D57207}"/>
+                <a16:creationId xmlns:a16="http://schemas.microsoft.com/office/drawing/2014/main" id="{951F51F1-C46C-4F91-9293-E6530494DACF}"/>
               </a:ext>
             </a:extLst>
           </p:cNvPr>
@@ -9597,7 +9597,7 @@
           <p:cNvPr id="3" name="">
             <a:extLst xmlns:a="http://schemas.openxmlformats.org/drawingml/2006/main">
               <a:ext uri="{FF2B5EF4-FFF2-40B4-BE49-F238E27FC236}">
-                <a16:creationId xmlns:a16="http://schemas.microsoft.com/office/drawing/2014/main" id="{7AD2331D-07A6-4A3D-B401-FF52887518A1}"/>
+                <a16:creationId xmlns:a16="http://schemas.microsoft.com/office/drawing/2014/main" id="{6048C05C-61DF-4497-8A4C-7486F14F468E}"/>
               </a:ext>
             </a:extLst>
           </p:cNvPr>
@@ -9627,7 +9627,7 @@
           <p:cNvPr id="4" name="18">
             <a:extLst xmlns:a="http://schemas.openxmlformats.org/drawingml/2006/main">
               <a:ext uri="{FF2B5EF4-FFF2-40B4-BE49-F238E27FC236}">
-                <a16:creationId xmlns:a16="http://schemas.microsoft.com/office/drawing/2014/main" id="{6DB212DD-77F6-4C6A-B22B-C8A82F31A578}"/>
+                <a16:creationId xmlns:a16="http://schemas.microsoft.com/office/drawing/2014/main" id="{0E9CCB8F-21F0-4D7E-AB72-B87A6DFD0038}"/>
               </a:ext>
             </a:extLst>
           </p:cNvPr>
@@ -9684,7 +9684,7 @@
           <p:cNvPr id="5" name="Un núcleo operativo completo&#10;con un ciclo de ingeniería veri">
             <a:extLst xmlns:a="http://schemas.openxmlformats.org/drawingml/2006/main">
               <a:ext uri="{FF2B5EF4-FFF2-40B4-BE49-F238E27FC236}">
-                <a16:creationId xmlns:a16="http://schemas.microsoft.com/office/drawing/2014/main" id="{8A2A5A76-3982-427E-912E-65C961E8E68C}"/>
+                <a16:creationId xmlns:a16="http://schemas.microsoft.com/office/drawing/2014/main" id="{921C97EF-C9C3-4F9B-A317-20D0F04F80CA}"/>
               </a:ext>
             </a:extLst>
           </p:cNvPr>
@@ -9764,7 +9764,7 @@
           <p:cNvPr id="6" name="Las necesidades se relacionan con el diseño y las pruebas.&#10;C">
             <a:extLst xmlns:a="http://schemas.openxmlformats.org/drawingml/2006/main">
               <a:ext uri="{FF2B5EF4-FFF2-40B4-BE49-F238E27FC236}">
-                <a16:creationId xmlns:a16="http://schemas.microsoft.com/office/drawing/2014/main" id="{F7FD1666-3EC9-4687-B5DC-B1618AA3DC6B}"/>
+                <a16:creationId xmlns:a16="http://schemas.microsoft.com/office/drawing/2014/main" id="{DCDADB7D-C1B1-44D4-8D1B-B29B5764F82D}"/>
               </a:ext>
             </a:extLst>
           </p:cNvPr>
@@ -9867,7 +9867,7 @@
           <p:cNvPr id="7" name="Gracias">
             <a:extLst xmlns:a="http://schemas.openxmlformats.org/drawingml/2006/main">
               <a:ext uri="{FF2B5EF4-FFF2-40B4-BE49-F238E27FC236}">
-                <a16:creationId xmlns:a16="http://schemas.microsoft.com/office/drawing/2014/main" id="{31B7B264-C00C-41CB-8562-27F97F8A855C}"/>
+                <a16:creationId xmlns:a16="http://schemas.microsoft.com/office/drawing/2014/main" id="{CEFC6275-2722-4CB6-AF30-33606DE3FCFA}"/>
               </a:ext>
             </a:extLst>
           </p:cNvPr>
@@ -9924,7 +9924,7 @@
           <p:cNvPr id="8" name="Preguntas">
             <a:extLst xmlns:a="http://schemas.openxmlformats.org/drawingml/2006/main">
               <a:ext uri="{FF2B5EF4-FFF2-40B4-BE49-F238E27FC236}">
-                <a16:creationId xmlns:a16="http://schemas.microsoft.com/office/drawing/2014/main" id="{15A568F7-7D51-42EA-AFC5-78993F18BD43}"/>
+                <a16:creationId xmlns:a16="http://schemas.microsoft.com/office/drawing/2014/main" id="{A4454EEC-2F29-4411-BF32-45E239FF3C0F}"/>
               </a:ext>
             </a:extLst>
           </p:cNvPr>
@@ -9981,7 +9981,7 @@
           <p:cNvPr id="9" name="Pablo Manzanares López · TransitOps">
             <a:extLst xmlns:a="http://schemas.openxmlformats.org/drawingml/2006/main">
               <a:ext uri="{FF2B5EF4-FFF2-40B4-BE49-F238E27FC236}">
-                <a16:creationId xmlns:a16="http://schemas.microsoft.com/office/drawing/2014/main" id="{165A96BC-0EE7-4BD9-81A7-23D87BB5880A}"/>
+                <a16:creationId xmlns:a16="http://schemas.microsoft.com/office/drawing/2014/main" id="{D1D022E3-4A65-40F6-BA5C-BED16523F4A6}"/>
               </a:ext>
             </a:extLst>
           </p:cNvPr>
@@ -10036,7 +10036,7 @@
     </p:spTree>
     <p:extLst>
       <p:ext uri="{BB962C8B-B14F-4D97-AF65-F5344CB8AC3E}">
-        <p14:creationId xmlns:p14="http://schemas.microsoft.com/office/powerpoint/2010/main" val="292818030"/>
+        <p14:creationId xmlns:p14="http://schemas.microsoft.com/office/powerpoint/2010/main" val="414030676"/>
       </p:ext>
     </p:extLst>
   </p:cSld>
@@ -10067,7 +10067,7 @@
           <p:cNvPr id="7" name="ANEXO">
             <a:extLst xmlns:a="http://schemas.openxmlformats.org/drawingml/2006/main">
               <a:ext uri="{FF2B5EF4-FFF2-40B4-BE49-F238E27FC236}">
-                <a16:creationId xmlns:a16="http://schemas.microsoft.com/office/drawing/2014/main" id="{938EDDFB-134F-4826-8169-4F1980A4B5F2}"/>
+                <a16:creationId xmlns:a16="http://schemas.microsoft.com/office/drawing/2014/main" id="{AEC720FE-2977-45F0-9525-608CDE051ADE}"/>
               </a:ext>
             </a:extLst>
           </p:cNvPr>
@@ -10124,7 +10124,7 @@
           <p:cNvPr id="2" name="Trazabilidad de requisitos">
             <a:extLst xmlns:a="http://schemas.openxmlformats.org/drawingml/2006/main">
               <a:ext uri="{FF2B5EF4-FFF2-40B4-BE49-F238E27FC236}">
-                <a16:creationId xmlns:a16="http://schemas.microsoft.com/office/drawing/2014/main" id="{6A7C2DA7-7821-468C-A3C3-301EADDACBF1}"/>
+                <a16:creationId xmlns:a16="http://schemas.microsoft.com/office/drawing/2014/main" id="{91D40C59-214A-41AB-83D9-3A210172565C}"/>
               </a:ext>
             </a:extLst>
           </p:cNvPr>
@@ -10181,7 +10181,7 @@
           <p:cNvPr id="3" name="">
             <a:extLst xmlns:a="http://schemas.openxmlformats.org/drawingml/2006/main">
               <a:ext uri="{FF2B5EF4-FFF2-40B4-BE49-F238E27FC236}">
-                <a16:creationId xmlns:a16="http://schemas.microsoft.com/office/drawing/2014/main" id="{3D784995-CA98-44D8-A50B-B0B38B039225}"/>
+                <a16:creationId xmlns:a16="http://schemas.microsoft.com/office/drawing/2014/main" id="{77E14377-F153-4D97-B648-CFE477191142}"/>
               </a:ext>
             </a:extLst>
           </p:cNvPr>
@@ -10211,7 +10211,7 @@
           <p:cNvPr id="4" name="A">
             <a:extLst xmlns:a="http://schemas.openxmlformats.org/drawingml/2006/main">
               <a:ext uri="{FF2B5EF4-FFF2-40B4-BE49-F238E27FC236}">
-                <a16:creationId xmlns:a16="http://schemas.microsoft.com/office/drawing/2014/main" id="{4CEB0C87-81C0-4DC8-AE62-64D6F68857CD}"/>
+                <a16:creationId xmlns:a16="http://schemas.microsoft.com/office/drawing/2014/main" id="{08CBB5F4-D865-420B-92B4-EF0A9EFB2CEF}"/>
               </a:ext>
             </a:extLst>
           </p:cNvPr>
@@ -10851,7 +10851,7 @@
           <p:cNvPr id="6" name="RF-04 incorpora la recuperación de contraseña administrativa">
             <a:extLst xmlns:a="http://schemas.openxmlformats.org/drawingml/2006/main">
               <a:ext uri="{FF2B5EF4-FFF2-40B4-BE49-F238E27FC236}">
-                <a16:creationId xmlns:a16="http://schemas.microsoft.com/office/drawing/2014/main" id="{CBD7738B-45D5-46CF-8B35-38450769672D}"/>
+                <a16:creationId xmlns:a16="http://schemas.microsoft.com/office/drawing/2014/main" id="{6B58DE6C-DC92-4F27-8874-38ECEB1C8834}"/>
               </a:ext>
             </a:extLst>
           </p:cNvPr>
@@ -10906,7 +10906,7 @@
     </p:spTree>
     <p:extLst>
       <p:ext uri="{BB962C8B-B14F-4D97-AF65-F5344CB8AC3E}">
-        <p14:creationId xmlns:p14="http://schemas.microsoft.com/office/powerpoint/2010/main" val="1414118237"/>
+        <p14:creationId xmlns:p14="http://schemas.microsoft.com/office/powerpoint/2010/main" val="1131397229"/>
       </p:ext>
     </p:extLst>
   </p:cSld>
@@ -10937,7 +10937,7 @@
           <p:cNvPr id="27" name="RECORRIDO">
             <a:extLst xmlns:a="http://schemas.openxmlformats.org/drawingml/2006/main">
               <a:ext uri="{FF2B5EF4-FFF2-40B4-BE49-F238E27FC236}">
-                <a16:creationId xmlns:a16="http://schemas.microsoft.com/office/drawing/2014/main" id="{1F60E326-332C-4B24-A5D2-79B0BEA5C212}"/>
+                <a16:creationId xmlns:a16="http://schemas.microsoft.com/office/drawing/2014/main" id="{7938F950-8033-47FB-8E94-F5DC690118BB}"/>
               </a:ext>
             </a:extLst>
           </p:cNvPr>
@@ -10994,7 +10994,7 @@
           <p:cNvPr id="2" name="Estructura de la presentación">
             <a:extLst xmlns:a="http://schemas.openxmlformats.org/drawingml/2006/main">
               <a:ext uri="{FF2B5EF4-FFF2-40B4-BE49-F238E27FC236}">
-                <a16:creationId xmlns:a16="http://schemas.microsoft.com/office/drawing/2014/main" id="{B10151D1-6858-4FF3-80B3-53FDA77F63AE}"/>
+                <a16:creationId xmlns:a16="http://schemas.microsoft.com/office/drawing/2014/main" id="{F49AE3E6-03AC-4B52-9DB4-7ECF03E32E77}"/>
               </a:ext>
             </a:extLst>
           </p:cNvPr>
@@ -11051,7 +11051,7 @@
           <p:cNvPr id="3" name="">
             <a:extLst xmlns:a="http://schemas.openxmlformats.org/drawingml/2006/main">
               <a:ext uri="{FF2B5EF4-FFF2-40B4-BE49-F238E27FC236}">
-                <a16:creationId xmlns:a16="http://schemas.microsoft.com/office/drawing/2014/main" id="{340A13FF-B53A-4318-B00E-9DDBB5849491}"/>
+                <a16:creationId xmlns:a16="http://schemas.microsoft.com/office/drawing/2014/main" id="{DEFB3B71-4814-47DC-B784-9D05FA05F1DD}"/>
               </a:ext>
             </a:extLst>
           </p:cNvPr>
@@ -11081,7 +11081,7 @@
           <p:cNvPr id="4" name="02">
             <a:extLst xmlns:a="http://schemas.openxmlformats.org/drawingml/2006/main">
               <a:ext uri="{FF2B5EF4-FFF2-40B4-BE49-F238E27FC236}">
-                <a16:creationId xmlns:a16="http://schemas.microsoft.com/office/drawing/2014/main" id="{1C8C95C2-6CA6-4051-A202-B86BE0D6A928}"/>
+                <a16:creationId xmlns:a16="http://schemas.microsoft.com/office/drawing/2014/main" id="{08BBC527-A6E3-49C0-B7E9-71F25B83C7A2}"/>
               </a:ext>
             </a:extLst>
           </p:cNvPr>
@@ -11138,7 +11138,7 @@
           <p:cNvPr id="5" name="01">
             <a:extLst xmlns:a="http://schemas.openxmlformats.org/drawingml/2006/main">
               <a:ext uri="{FF2B5EF4-FFF2-40B4-BE49-F238E27FC236}">
-                <a16:creationId xmlns:a16="http://schemas.microsoft.com/office/drawing/2014/main" id="{B3D9084D-EBE1-4715-AC30-23A27504CBF9}"/>
+                <a16:creationId xmlns:a16="http://schemas.microsoft.com/office/drawing/2014/main" id="{A3FB5A90-C92A-4FBE-B180-FA2162D6183C}"/>
               </a:ext>
             </a:extLst>
           </p:cNvPr>
@@ -11195,7 +11195,7 @@
           <p:cNvPr id="6" name="Problema y objetivos">
             <a:extLst xmlns:a="http://schemas.openxmlformats.org/drawingml/2006/main">
               <a:ext uri="{FF2B5EF4-FFF2-40B4-BE49-F238E27FC236}">
-                <a16:creationId xmlns:a16="http://schemas.microsoft.com/office/drawing/2014/main" id="{0E68AEB9-B3B9-44E3-B24B-5ED072646FF5}"/>
+                <a16:creationId xmlns:a16="http://schemas.microsoft.com/office/drawing/2014/main" id="{0A206BF0-C43E-4BFC-AC8B-A7DCCF7EEEB1}"/>
               </a:ext>
             </a:extLst>
           </p:cNvPr>
@@ -11252,7 +11252,7 @@
           <p:cNvPr id="7" name="">
             <a:extLst xmlns:a="http://schemas.openxmlformats.org/drawingml/2006/main">
               <a:ext uri="{FF2B5EF4-FFF2-40B4-BE49-F238E27FC236}">
-                <a16:creationId xmlns:a16="http://schemas.microsoft.com/office/drawing/2014/main" id="{CDA06383-4285-4325-9FC5-2AE7C476666C}"/>
+                <a16:creationId xmlns:a16="http://schemas.microsoft.com/office/drawing/2014/main" id="{E8D1483F-8843-43F1-9E20-9F58A2C8160A}"/>
               </a:ext>
             </a:extLst>
           </p:cNvPr>
@@ -11282,7 +11282,7 @@
           <p:cNvPr id="8" name="02">
             <a:extLst xmlns:a="http://schemas.openxmlformats.org/drawingml/2006/main">
               <a:ext uri="{FF2B5EF4-FFF2-40B4-BE49-F238E27FC236}">
-                <a16:creationId xmlns:a16="http://schemas.microsoft.com/office/drawing/2014/main" id="{432002D1-49F7-4F49-B40A-04531F57585B}"/>
+                <a16:creationId xmlns:a16="http://schemas.microsoft.com/office/drawing/2014/main" id="{23649FE7-93F3-411C-94B1-6A04B5E806E3}"/>
               </a:ext>
             </a:extLst>
           </p:cNvPr>
@@ -11339,7 +11339,7 @@
           <p:cNvPr id="9" name="Requisitos y alcance">
             <a:extLst xmlns:a="http://schemas.openxmlformats.org/drawingml/2006/main">
               <a:ext uri="{FF2B5EF4-FFF2-40B4-BE49-F238E27FC236}">
-                <a16:creationId xmlns:a16="http://schemas.microsoft.com/office/drawing/2014/main" id="{E46264C4-F456-4142-87A7-CA5E6DA528FC}"/>
+                <a16:creationId xmlns:a16="http://schemas.microsoft.com/office/drawing/2014/main" id="{0E34D6E0-5CAB-4F64-8F1B-A1B5234941DD}"/>
               </a:ext>
             </a:extLst>
           </p:cNvPr>
@@ -11396,7 +11396,7 @@
           <p:cNvPr id="10" name="">
             <a:extLst xmlns:a="http://schemas.openxmlformats.org/drawingml/2006/main">
               <a:ext uri="{FF2B5EF4-FFF2-40B4-BE49-F238E27FC236}">
-                <a16:creationId xmlns:a16="http://schemas.microsoft.com/office/drawing/2014/main" id="{3165121E-CF3D-4E8E-80AB-07CFB014E54D}"/>
+                <a16:creationId xmlns:a16="http://schemas.microsoft.com/office/drawing/2014/main" id="{06E46FD9-36A5-43D6-B9B5-7FF8F80F81D5}"/>
               </a:ext>
             </a:extLst>
           </p:cNvPr>
@@ -11426,7 +11426,7 @@
           <p:cNvPr id="11" name="03">
             <a:extLst xmlns:a="http://schemas.openxmlformats.org/drawingml/2006/main">
               <a:ext uri="{FF2B5EF4-FFF2-40B4-BE49-F238E27FC236}">
-                <a16:creationId xmlns:a16="http://schemas.microsoft.com/office/drawing/2014/main" id="{ADE9F0FC-E8CA-40AE-A3D2-69BF167C0E0C}"/>
+                <a16:creationId xmlns:a16="http://schemas.microsoft.com/office/drawing/2014/main" id="{1E292773-6A28-46B8-8999-1AAC2F456E1A}"/>
               </a:ext>
             </a:extLst>
           </p:cNvPr>
@@ -11483,7 +11483,7 @@
           <p:cNvPr id="12" name="Metodología">
             <a:extLst xmlns:a="http://schemas.openxmlformats.org/drawingml/2006/main">
               <a:ext uri="{FF2B5EF4-FFF2-40B4-BE49-F238E27FC236}">
-                <a16:creationId xmlns:a16="http://schemas.microsoft.com/office/drawing/2014/main" id="{B9E4C72E-DE02-4FE8-894F-4B8BA0AC87F1}"/>
+                <a16:creationId xmlns:a16="http://schemas.microsoft.com/office/drawing/2014/main" id="{14A004F1-6CFF-4565-BA6D-1D331D8A8A67}"/>
               </a:ext>
             </a:extLst>
           </p:cNvPr>
@@ -11540,7 +11540,7 @@
           <p:cNvPr id="13" name="">
             <a:extLst xmlns:a="http://schemas.openxmlformats.org/drawingml/2006/main">
               <a:ext uri="{FF2B5EF4-FFF2-40B4-BE49-F238E27FC236}">
-                <a16:creationId xmlns:a16="http://schemas.microsoft.com/office/drawing/2014/main" id="{1EC51AD8-FBF0-48C9-9EAC-DD33FCD14CF0}"/>
+                <a16:creationId xmlns:a16="http://schemas.microsoft.com/office/drawing/2014/main" id="{FF3309F8-A5A7-4A3E-B67D-5B01C89BCFEC}"/>
               </a:ext>
             </a:extLst>
           </p:cNvPr>
@@ -11570,7 +11570,7 @@
           <p:cNvPr id="14" name="04">
             <a:extLst xmlns:a="http://schemas.openxmlformats.org/drawingml/2006/main">
               <a:ext uri="{FF2B5EF4-FFF2-40B4-BE49-F238E27FC236}">
-                <a16:creationId xmlns:a16="http://schemas.microsoft.com/office/drawing/2014/main" id="{915D5016-E5B0-48D6-A0FF-DA4DBA72A807}"/>
+                <a16:creationId xmlns:a16="http://schemas.microsoft.com/office/drawing/2014/main" id="{1A68445E-AAE5-4A17-88EB-465615FAD84A}"/>
               </a:ext>
             </a:extLst>
           </p:cNvPr>
@@ -11627,7 +11627,7 @@
           <p:cNvPr id="15" name="Diseño y arquitectura">
             <a:extLst xmlns:a="http://schemas.openxmlformats.org/drawingml/2006/main">
               <a:ext uri="{FF2B5EF4-FFF2-40B4-BE49-F238E27FC236}">
-                <a16:creationId xmlns:a16="http://schemas.microsoft.com/office/drawing/2014/main" id="{5D4957B9-8AC4-43EB-8DB9-731A54DB77D1}"/>
+                <a16:creationId xmlns:a16="http://schemas.microsoft.com/office/drawing/2014/main" id="{2BD1E9DA-8D01-464B-B9DC-4BDCB3AADCD0}"/>
               </a:ext>
             </a:extLst>
           </p:cNvPr>
@@ -11684,7 +11684,7 @@
           <p:cNvPr id="16" name="">
             <a:extLst xmlns:a="http://schemas.openxmlformats.org/drawingml/2006/main">
               <a:ext uri="{FF2B5EF4-FFF2-40B4-BE49-F238E27FC236}">
-                <a16:creationId xmlns:a16="http://schemas.microsoft.com/office/drawing/2014/main" id="{2E72EE87-FC5B-4276-B642-6404303E9383}"/>
+                <a16:creationId xmlns:a16="http://schemas.microsoft.com/office/drawing/2014/main" id="{E3CA4DFA-D57A-4E94-989F-CBE838DBF9DB}"/>
               </a:ext>
             </a:extLst>
           </p:cNvPr>
@@ -11714,7 +11714,7 @@
           <p:cNvPr id="17" name="05">
             <a:extLst xmlns:a="http://schemas.openxmlformats.org/drawingml/2006/main">
               <a:ext uri="{FF2B5EF4-FFF2-40B4-BE49-F238E27FC236}">
-                <a16:creationId xmlns:a16="http://schemas.microsoft.com/office/drawing/2014/main" id="{95C191D7-5940-480F-910D-77060591C108}"/>
+                <a16:creationId xmlns:a16="http://schemas.microsoft.com/office/drawing/2014/main" id="{0A04F9FB-037B-4ECA-B724-8EE9339355C9}"/>
               </a:ext>
             </a:extLst>
           </p:cNvPr>
@@ -11771,7 +11771,7 @@
           <p:cNvPr id="18" name="Demostración funcional">
             <a:extLst xmlns:a="http://schemas.openxmlformats.org/drawingml/2006/main">
               <a:ext uri="{FF2B5EF4-FFF2-40B4-BE49-F238E27FC236}">
-                <a16:creationId xmlns:a16="http://schemas.microsoft.com/office/drawing/2014/main" id="{A0AC6FAC-1E2E-414B-AC6D-FA9768788FB1}"/>
+                <a16:creationId xmlns:a16="http://schemas.microsoft.com/office/drawing/2014/main" id="{F0018343-D0B1-40F7-847B-27A41C9673F4}"/>
               </a:ext>
             </a:extLst>
           </p:cNvPr>
@@ -11828,7 +11828,7 @@
           <p:cNvPr id="19" name="">
             <a:extLst xmlns:a="http://schemas.openxmlformats.org/drawingml/2006/main">
               <a:ext uri="{FF2B5EF4-FFF2-40B4-BE49-F238E27FC236}">
-                <a16:creationId xmlns:a16="http://schemas.microsoft.com/office/drawing/2014/main" id="{0367EFD3-D426-4C94-927F-197EA0C0036A}"/>
+                <a16:creationId xmlns:a16="http://schemas.microsoft.com/office/drawing/2014/main" id="{C7E1BEBA-B182-4BE7-9EC7-E8F55B1E6B44}"/>
               </a:ext>
             </a:extLst>
           </p:cNvPr>
@@ -11858,7 +11858,7 @@
           <p:cNvPr id="20" name="06">
             <a:extLst xmlns:a="http://schemas.openxmlformats.org/drawingml/2006/main">
               <a:ext uri="{FF2B5EF4-FFF2-40B4-BE49-F238E27FC236}">
-                <a16:creationId xmlns:a16="http://schemas.microsoft.com/office/drawing/2014/main" id="{AEA50D35-BAE9-426F-B81B-AB180BD79B5B}"/>
+                <a16:creationId xmlns:a16="http://schemas.microsoft.com/office/drawing/2014/main" id="{CCF7852A-EA0E-4AC2-8EC7-7AD8FC5C3B94}"/>
               </a:ext>
             </a:extLst>
           </p:cNvPr>
@@ -11915,7 +11915,7 @@
           <p:cNvPr id="21" name="Validación y despliegue">
             <a:extLst xmlns:a="http://schemas.openxmlformats.org/drawingml/2006/main">
               <a:ext uri="{FF2B5EF4-FFF2-40B4-BE49-F238E27FC236}">
-                <a16:creationId xmlns:a16="http://schemas.microsoft.com/office/drawing/2014/main" id="{EE804C77-CC58-455E-AEDC-42D85C28E7E3}"/>
+                <a16:creationId xmlns:a16="http://schemas.microsoft.com/office/drawing/2014/main" id="{3F48051D-4D01-40C5-A48D-9FFC73D42442}"/>
               </a:ext>
             </a:extLst>
           </p:cNvPr>
@@ -11972,7 +11972,7 @@
           <p:cNvPr id="22" name="">
             <a:extLst xmlns:a="http://schemas.openxmlformats.org/drawingml/2006/main">
               <a:ext uri="{FF2B5EF4-FFF2-40B4-BE49-F238E27FC236}">
-                <a16:creationId xmlns:a16="http://schemas.microsoft.com/office/drawing/2014/main" id="{E22C7454-25A4-4775-91DF-89A7B19984E3}"/>
+                <a16:creationId xmlns:a16="http://schemas.microsoft.com/office/drawing/2014/main" id="{4D4789FE-AFC5-471D-8402-9EDB157092B8}"/>
               </a:ext>
             </a:extLst>
           </p:cNvPr>
@@ -12002,7 +12002,7 @@
           <p:cNvPr id="23" name="07">
             <a:extLst xmlns:a="http://schemas.openxmlformats.org/drawingml/2006/main">
               <a:ext uri="{FF2B5EF4-FFF2-40B4-BE49-F238E27FC236}">
-                <a16:creationId xmlns:a16="http://schemas.microsoft.com/office/drawing/2014/main" id="{F647164E-BAAC-46DD-80D5-2F1C8AC97750}"/>
+                <a16:creationId xmlns:a16="http://schemas.microsoft.com/office/drawing/2014/main" id="{E6FB9E99-1C85-4D3C-9A61-F0EAD5C11AFA}"/>
               </a:ext>
             </a:extLst>
           </p:cNvPr>
@@ -12059,7 +12059,7 @@
           <p:cNvPr id="24" name="Conclusiones y trabajo futuro">
             <a:extLst xmlns:a="http://schemas.openxmlformats.org/drawingml/2006/main">
               <a:ext uri="{FF2B5EF4-FFF2-40B4-BE49-F238E27FC236}">
-                <a16:creationId xmlns:a16="http://schemas.microsoft.com/office/drawing/2014/main" id="{C2BDB1BD-811C-4D6F-93AD-2C455521C98E}"/>
+                <a16:creationId xmlns:a16="http://schemas.microsoft.com/office/drawing/2014/main" id="{EDF76AD1-1DF6-4C3D-ADAD-656501A7B739}"/>
               </a:ext>
             </a:extLst>
           </p:cNvPr>
@@ -12116,7 +12116,7 @@
           <p:cNvPr id="25" name="">
             <a:extLst xmlns:a="http://schemas.openxmlformats.org/drawingml/2006/main">
               <a:ext uri="{FF2B5EF4-FFF2-40B4-BE49-F238E27FC236}">
-                <a16:creationId xmlns:a16="http://schemas.microsoft.com/office/drawing/2014/main" id="{8349D93E-8E08-4A4F-87ED-B9B72DC00BAA}"/>
+                <a16:creationId xmlns:a16="http://schemas.microsoft.com/office/drawing/2014/main" id="{88FCB6B8-CA22-44A0-910E-C61C410E122B}"/>
               </a:ext>
             </a:extLst>
           </p:cNvPr>
@@ -12146,7 +12146,7 @@
           <p:cNvPr id="26" name="Orden de la defensa: definición, construcción, demostración ">
             <a:extLst xmlns:a="http://schemas.openxmlformats.org/drawingml/2006/main">
               <a:ext uri="{FF2B5EF4-FFF2-40B4-BE49-F238E27FC236}">
-                <a16:creationId xmlns:a16="http://schemas.microsoft.com/office/drawing/2014/main" id="{89405A23-7CD9-4279-9EBB-25562F21C5BA}"/>
+                <a16:creationId xmlns:a16="http://schemas.microsoft.com/office/drawing/2014/main" id="{5A0326A2-877E-4722-AE21-78CFAF071899}"/>
               </a:ext>
             </a:extLst>
           </p:cNvPr>
@@ -12201,7 +12201,7 @@
     </p:spTree>
     <p:extLst>
       <p:ext uri="{BB962C8B-B14F-4D97-AF65-F5344CB8AC3E}">
-        <p14:creationId xmlns:p14="http://schemas.microsoft.com/office/powerpoint/2010/main" val="769444392"/>
+        <p14:creationId xmlns:p14="http://schemas.microsoft.com/office/powerpoint/2010/main" val="1721943043"/>
       </p:ext>
     </p:extLst>
   </p:cSld>
@@ -12232,7 +12232,7 @@
           <p:cNvPr id="7" name="ANEXO">
             <a:extLst xmlns:a="http://schemas.openxmlformats.org/drawingml/2006/main">
               <a:ext uri="{FF2B5EF4-FFF2-40B4-BE49-F238E27FC236}">
-                <a16:creationId xmlns:a16="http://schemas.microsoft.com/office/drawing/2014/main" id="{AE171973-F119-44F3-86F4-3F28AA6276D4}"/>
+                <a16:creationId xmlns:a16="http://schemas.microsoft.com/office/drawing/2014/main" id="{86139A64-23F1-4702-9083-D69566988B7D}"/>
               </a:ext>
             </a:extLst>
           </p:cNvPr>
@@ -12289,7 +12289,7 @@
           <p:cNvPr id="2" name="Concurrencia y seguridad">
             <a:extLst xmlns:a="http://schemas.openxmlformats.org/drawingml/2006/main">
               <a:ext uri="{FF2B5EF4-FFF2-40B4-BE49-F238E27FC236}">
-                <a16:creationId xmlns:a16="http://schemas.microsoft.com/office/drawing/2014/main" id="{D8287BD8-14A4-474D-805A-A1E43A15492B}"/>
+                <a16:creationId xmlns:a16="http://schemas.microsoft.com/office/drawing/2014/main" id="{44B2BDB0-8876-4880-9F48-432FC7177CF2}"/>
               </a:ext>
             </a:extLst>
           </p:cNvPr>
@@ -12346,7 +12346,7 @@
           <p:cNvPr id="3" name="">
             <a:extLst xmlns:a="http://schemas.openxmlformats.org/drawingml/2006/main">
               <a:ext uri="{FF2B5EF4-FFF2-40B4-BE49-F238E27FC236}">
-                <a16:creationId xmlns:a16="http://schemas.microsoft.com/office/drawing/2014/main" id="{B4145CE2-1CA0-418B-8A84-731ADC68E478}"/>
+                <a16:creationId xmlns:a16="http://schemas.microsoft.com/office/drawing/2014/main" id="{74FA6D54-29D6-43CF-9A4D-791A108E5148}"/>
               </a:ext>
             </a:extLst>
           </p:cNvPr>
@@ -12376,7 +12376,7 @@
           <p:cNvPr id="4" name="B">
             <a:extLst xmlns:a="http://schemas.openxmlformats.org/drawingml/2006/main">
               <a:ext uri="{FF2B5EF4-FFF2-40B4-BE49-F238E27FC236}">
-                <a16:creationId xmlns:a16="http://schemas.microsoft.com/office/drawing/2014/main" id="{087F08D0-9A7B-4075-903C-3957A21E3AA0}"/>
+                <a16:creationId xmlns:a16="http://schemas.microsoft.com/office/drawing/2014/main" id="{B52D857F-CF24-4F95-B883-9BD6555D0EAF}"/>
               </a:ext>
             </a:extLst>
           </p:cNvPr>
@@ -12856,7 +12856,7 @@
           <p:cNvPr id="6" name="Memoria, pp. 25–33 y 52–54.">
             <a:extLst xmlns:a="http://schemas.openxmlformats.org/drawingml/2006/main">
               <a:ext uri="{FF2B5EF4-FFF2-40B4-BE49-F238E27FC236}">
-                <a16:creationId xmlns:a16="http://schemas.microsoft.com/office/drawing/2014/main" id="{1CE94422-E77F-4C69-961C-BF98FB6E66AA}"/>
+                <a16:creationId xmlns:a16="http://schemas.microsoft.com/office/drawing/2014/main" id="{C71FAB24-A922-409C-AC74-4E7929C22BB7}"/>
               </a:ext>
             </a:extLst>
           </p:cNvPr>
@@ -12911,7 +12911,7 @@
     </p:spTree>
     <p:extLst>
       <p:ext uri="{BB962C8B-B14F-4D97-AF65-F5344CB8AC3E}">
-        <p14:creationId xmlns:p14="http://schemas.microsoft.com/office/powerpoint/2010/main" val="160769945"/>
+        <p14:creationId xmlns:p14="http://schemas.microsoft.com/office/powerpoint/2010/main" val="2132289608"/>
       </p:ext>
     </p:extLst>
   </p:cSld>
@@ -12942,7 +12942,7 @@
           <p:cNvPr id="7" name="ANEXO">
             <a:extLst xmlns:a="http://schemas.openxmlformats.org/drawingml/2006/main">
               <a:ext uri="{FF2B5EF4-FFF2-40B4-BE49-F238E27FC236}">
-                <a16:creationId xmlns:a16="http://schemas.microsoft.com/office/drawing/2014/main" id="{B821A085-AAB9-4462-9CB8-FF0A45565DA1}"/>
+                <a16:creationId xmlns:a16="http://schemas.microsoft.com/office/drawing/2014/main" id="{686FE30C-C574-498D-A29D-28ED7A7E07E8}"/>
               </a:ext>
             </a:extLst>
           </p:cNvPr>
@@ -12999,7 +12999,7 @@
           <p:cNvPr id="2" name="Planificación y coste">
             <a:extLst xmlns:a="http://schemas.openxmlformats.org/drawingml/2006/main">
               <a:ext uri="{FF2B5EF4-FFF2-40B4-BE49-F238E27FC236}">
-                <a16:creationId xmlns:a16="http://schemas.microsoft.com/office/drawing/2014/main" id="{A98F96AE-F64A-4CE6-BE59-E6D8D015F10D}"/>
+                <a16:creationId xmlns:a16="http://schemas.microsoft.com/office/drawing/2014/main" id="{6485D6B1-4ABB-4042-A84B-B995A66A3773}"/>
               </a:ext>
             </a:extLst>
           </p:cNvPr>
@@ -13056,7 +13056,7 @@
           <p:cNvPr id="3" name="">
             <a:extLst xmlns:a="http://schemas.openxmlformats.org/drawingml/2006/main">
               <a:ext uri="{FF2B5EF4-FFF2-40B4-BE49-F238E27FC236}">
-                <a16:creationId xmlns:a16="http://schemas.microsoft.com/office/drawing/2014/main" id="{8C26D72E-7AFE-4CE8-B332-DB488831E53B}"/>
+                <a16:creationId xmlns:a16="http://schemas.microsoft.com/office/drawing/2014/main" id="{CD682D89-50F5-466E-90DB-3DED3A8EA7DD}"/>
               </a:ext>
             </a:extLst>
           </p:cNvPr>
@@ -13086,7 +13086,7 @@
           <p:cNvPr id="4" name="C">
             <a:extLst xmlns:a="http://schemas.openxmlformats.org/drawingml/2006/main">
               <a:ext uri="{FF2B5EF4-FFF2-40B4-BE49-F238E27FC236}">
-                <a16:creationId xmlns:a16="http://schemas.microsoft.com/office/drawing/2014/main" id="{3F5626C2-585F-443C-99BE-82B3EF974DE4}"/>
+                <a16:creationId xmlns:a16="http://schemas.microsoft.com/office/drawing/2014/main" id="{3926CBC1-04B6-4037-96F6-0ABB547EB792}"/>
               </a:ext>
             </a:extLst>
           </p:cNvPr>
@@ -13726,7 +13726,7 @@
           <p:cNvPr id="6" name="Estimación académica de la memoria, tabla 3.3, p. 13. No rep">
             <a:extLst xmlns:a="http://schemas.openxmlformats.org/drawingml/2006/main">
               <a:ext uri="{FF2B5EF4-FFF2-40B4-BE49-F238E27FC236}">
-                <a16:creationId xmlns:a16="http://schemas.microsoft.com/office/drawing/2014/main" id="{82C962E0-3255-4335-AD80-D78633D9D2D0}"/>
+                <a16:creationId xmlns:a16="http://schemas.microsoft.com/office/drawing/2014/main" id="{25AC6BB6-C6D8-489F-BEDE-8C7A33EC7B93}"/>
               </a:ext>
             </a:extLst>
           </p:cNvPr>
@@ -13781,7 +13781,7 @@
     </p:spTree>
     <p:extLst>
       <p:ext uri="{BB962C8B-B14F-4D97-AF65-F5344CB8AC3E}">
-        <p14:creationId xmlns:p14="http://schemas.microsoft.com/office/powerpoint/2010/main" val="583545597"/>
+        <p14:creationId xmlns:p14="http://schemas.microsoft.com/office/powerpoint/2010/main" val="152175722"/>
       </p:ext>
     </p:extLst>
   </p:cSld>
@@ -13812,7 +13812,7 @@
           <p:cNvPr id="7" name="ANEXO">
             <a:extLst xmlns:a="http://schemas.openxmlformats.org/drawingml/2006/main">
               <a:ext uri="{FF2B5EF4-FFF2-40B4-BE49-F238E27FC236}">
-                <a16:creationId xmlns:a16="http://schemas.microsoft.com/office/drawing/2014/main" id="{2CCB1B55-60B0-41A6-89DB-AA355F0375ED}"/>
+                <a16:creationId xmlns:a16="http://schemas.microsoft.com/office/drawing/2014/main" id="{5D218CBB-6368-49CA-BBC6-E12C3932821B}"/>
               </a:ext>
             </a:extLst>
           </p:cNvPr>
@@ -13869,7 +13869,7 @@
           <p:cNvPr id="2" name="Evolución de las pruebas">
             <a:extLst xmlns:a="http://schemas.openxmlformats.org/drawingml/2006/main">
               <a:ext uri="{FF2B5EF4-FFF2-40B4-BE49-F238E27FC236}">
-                <a16:creationId xmlns:a16="http://schemas.microsoft.com/office/drawing/2014/main" id="{48DB4C6F-99AC-4A6E-A3E0-AF5AA02B392F}"/>
+                <a16:creationId xmlns:a16="http://schemas.microsoft.com/office/drawing/2014/main" id="{C6141039-2239-4547-9AE9-719CA19EA33B}"/>
               </a:ext>
             </a:extLst>
           </p:cNvPr>
@@ -13926,7 +13926,7 @@
           <p:cNvPr id="3" name="">
             <a:extLst xmlns:a="http://schemas.openxmlformats.org/drawingml/2006/main">
               <a:ext uri="{FF2B5EF4-FFF2-40B4-BE49-F238E27FC236}">
-                <a16:creationId xmlns:a16="http://schemas.microsoft.com/office/drawing/2014/main" id="{B7475A83-0DAB-413A-97D6-4143F1E99C91}"/>
+                <a16:creationId xmlns:a16="http://schemas.microsoft.com/office/drawing/2014/main" id="{F4F80B3F-0CA0-4A50-9CD6-02468A7AC3F6}"/>
               </a:ext>
             </a:extLst>
           </p:cNvPr>
@@ -13956,7 +13956,7 @@
           <p:cNvPr id="4" name="D">
             <a:extLst xmlns:a="http://schemas.openxmlformats.org/drawingml/2006/main">
               <a:ext uri="{FF2B5EF4-FFF2-40B4-BE49-F238E27FC236}">
-                <a16:creationId xmlns:a16="http://schemas.microsoft.com/office/drawing/2014/main" id="{2EE6942C-5C63-4AB0-BC88-4CBAD79DF53A}"/>
+                <a16:creationId xmlns:a16="http://schemas.microsoft.com/office/drawing/2014/main" id="{8C10A130-9B8C-4441-A89A-837738DEA1A1}"/>
               </a:ext>
             </a:extLst>
           </p:cNvPr>
@@ -14885,7 +14885,7 @@
           <p:cNvPr id="6" name="Recuentos acumulados documentados al cierre de cada sprint. ">
             <a:extLst xmlns:a="http://schemas.openxmlformats.org/drawingml/2006/main">
               <a:ext uri="{FF2B5EF4-FFF2-40B4-BE49-F238E27FC236}">
-                <a16:creationId xmlns:a16="http://schemas.microsoft.com/office/drawing/2014/main" id="{526E76AE-F92C-4950-BDF4-E02C7F4BE960}"/>
+                <a16:creationId xmlns:a16="http://schemas.microsoft.com/office/drawing/2014/main" id="{A3F4270A-97E5-4E86-84ED-6CF8C300251F}"/>
               </a:ext>
             </a:extLst>
           </p:cNvPr>
@@ -14940,7 +14940,7 @@
     </p:spTree>
     <p:extLst>
       <p:ext uri="{BB962C8B-B14F-4D97-AF65-F5344CB8AC3E}">
-        <p14:creationId xmlns:p14="http://schemas.microsoft.com/office/powerpoint/2010/main" val="920028218"/>
+        <p14:creationId xmlns:p14="http://schemas.microsoft.com/office/powerpoint/2010/main" val="1360065101"/>
       </p:ext>
     </p:extLst>
   </p:cSld>
@@ -14971,7 +14971,7 @@
           <p:cNvPr id="14" name="01 · PROBLEMA Y OBJETIVOS">
             <a:extLst xmlns:a="http://schemas.openxmlformats.org/drawingml/2006/main">
               <a:ext uri="{FF2B5EF4-FFF2-40B4-BE49-F238E27FC236}">
-                <a16:creationId xmlns:a16="http://schemas.microsoft.com/office/drawing/2014/main" id="{F6A8037B-A981-4700-A484-E199598B220A}"/>
+                <a16:creationId xmlns:a16="http://schemas.microsoft.com/office/drawing/2014/main" id="{CEBBEC02-4B92-4353-8662-1261F990BF57}"/>
               </a:ext>
             </a:extLst>
           </p:cNvPr>
@@ -15028,7 +15028,7 @@
           <p:cNvPr id="2" name="Problema de partida">
             <a:extLst xmlns:a="http://schemas.openxmlformats.org/drawingml/2006/main">
               <a:ext uri="{FF2B5EF4-FFF2-40B4-BE49-F238E27FC236}">
-                <a16:creationId xmlns:a16="http://schemas.microsoft.com/office/drawing/2014/main" id="{9596CA6C-13FC-407C-AE65-FE0C01D9AC12}"/>
+                <a16:creationId xmlns:a16="http://schemas.microsoft.com/office/drawing/2014/main" id="{A49D4BE7-A8FB-4F03-8499-CBD95CF2C723}"/>
               </a:ext>
             </a:extLst>
           </p:cNvPr>
@@ -15085,7 +15085,7 @@
           <p:cNvPr id="3" name="">
             <a:extLst xmlns:a="http://schemas.openxmlformats.org/drawingml/2006/main">
               <a:ext uri="{FF2B5EF4-FFF2-40B4-BE49-F238E27FC236}">
-                <a16:creationId xmlns:a16="http://schemas.microsoft.com/office/drawing/2014/main" id="{8AABC0F0-51FC-493C-BDDC-2CC3FD4FEF97}"/>
+                <a16:creationId xmlns:a16="http://schemas.microsoft.com/office/drawing/2014/main" id="{2976F36B-BF56-4F31-9582-44C0A3E5F51F}"/>
               </a:ext>
             </a:extLst>
           </p:cNvPr>
@@ -15115,7 +15115,7 @@
           <p:cNvPr id="4" name="03">
             <a:extLst xmlns:a="http://schemas.openxmlformats.org/drawingml/2006/main">
               <a:ext uri="{FF2B5EF4-FFF2-40B4-BE49-F238E27FC236}">
-                <a16:creationId xmlns:a16="http://schemas.microsoft.com/office/drawing/2014/main" id="{7F58C739-93B4-4832-A0BB-D96692B43AB1}"/>
+                <a16:creationId xmlns:a16="http://schemas.microsoft.com/office/drawing/2014/main" id="{C71F2FA0-D799-40E5-9482-535ED86C1A79}"/>
               </a:ext>
             </a:extLst>
           </p:cNvPr>
@@ -15172,7 +15172,7 @@
           <p:cNvPr id="5" name="La información operativa está repartida entre hojas, mensaje">
             <a:extLst xmlns:a="http://schemas.openxmlformats.org/drawingml/2006/main">
               <a:ext uri="{FF2B5EF4-FFF2-40B4-BE49-F238E27FC236}">
-                <a16:creationId xmlns:a16="http://schemas.microsoft.com/office/drawing/2014/main" id="{BD002B01-124A-4671-B964-1E8586E07C59}"/>
+                <a16:creationId xmlns:a16="http://schemas.microsoft.com/office/drawing/2014/main" id="{F18BB16F-D88B-4922-B03F-D845AF951D16}"/>
               </a:ext>
             </a:extLst>
           </p:cNvPr>
@@ -15229,7 +15229,7 @@
           <p:cNvPr id="6" name="Disponibilidad incierta">
             <a:extLst xmlns:a="http://schemas.openxmlformats.org/drawingml/2006/main">
               <a:ext uri="{FF2B5EF4-FFF2-40B4-BE49-F238E27FC236}">
-                <a16:creationId xmlns:a16="http://schemas.microsoft.com/office/drawing/2014/main" id="{5012ACFC-D315-4C8D-9108-D328C501C5FE}"/>
+                <a16:creationId xmlns:a16="http://schemas.microsoft.com/office/drawing/2014/main" id="{04789987-9FF9-4505-B8B5-7BB6F6B118C4}"/>
               </a:ext>
             </a:extLst>
           </p:cNvPr>
@@ -15286,7 +15286,7 @@
           <p:cNvPr id="7" name="Un vehículo o conductor puede quedar reservado dos veces.">
             <a:extLst xmlns:a="http://schemas.openxmlformats.org/drawingml/2006/main">
               <a:ext uri="{FF2B5EF4-FFF2-40B4-BE49-F238E27FC236}">
-                <a16:creationId xmlns:a16="http://schemas.microsoft.com/office/drawing/2014/main" id="{8CB33C91-51B1-4E05-B6E4-ACE3250AC8CB}"/>
+                <a16:creationId xmlns:a16="http://schemas.microsoft.com/office/drawing/2014/main" id="{871FE00A-A1ED-493F-9A62-38CF08B25896}"/>
               </a:ext>
             </a:extLst>
           </p:cNvPr>
@@ -15343,7 +15343,7 @@
           <p:cNvPr id="8" name="Historia incompleta">
             <a:extLst xmlns:a="http://schemas.openxmlformats.org/drawingml/2006/main">
               <a:ext uri="{FF2B5EF4-FFF2-40B4-BE49-F238E27FC236}">
-                <a16:creationId xmlns:a16="http://schemas.microsoft.com/office/drawing/2014/main" id="{1ADC0C69-F289-480F-AC69-7EC67BC1B8D0}"/>
+                <a16:creationId xmlns:a16="http://schemas.microsoft.com/office/drawing/2014/main" id="{DCE7F0AB-1808-41F1-85DF-8E46C6B1A248}"/>
               </a:ext>
             </a:extLst>
           </p:cNvPr>
@@ -15400,7 +15400,7 @@
           <p:cNvPr id="9" name="Reconstruir una incidencia exige buscar qué pasó y quién act">
             <a:extLst xmlns:a="http://schemas.openxmlformats.org/drawingml/2006/main">
               <a:ext uri="{FF2B5EF4-FFF2-40B4-BE49-F238E27FC236}">
-                <a16:creationId xmlns:a16="http://schemas.microsoft.com/office/drawing/2014/main" id="{C8CB32D5-716E-4B59-8168-ACB3B462F73A}"/>
+                <a16:creationId xmlns:a16="http://schemas.microsoft.com/office/drawing/2014/main" id="{8F0D9C73-D067-45AF-92E8-83DF5D6B9D59}"/>
               </a:ext>
             </a:extLst>
           </p:cNvPr>
@@ -15457,7 +15457,7 @@
           <p:cNvPr id="10" name="Datos sin vigencia clara">
             <a:extLst xmlns:a="http://schemas.openxmlformats.org/drawingml/2006/main">
               <a:ext uri="{FF2B5EF4-FFF2-40B4-BE49-F238E27FC236}">
-                <a16:creationId xmlns:a16="http://schemas.microsoft.com/office/drawing/2014/main" id="{5348C210-48B1-46DD-871A-98D9078EA4D4}"/>
+                <a16:creationId xmlns:a16="http://schemas.microsoft.com/office/drawing/2014/main" id="{966687B6-3BA5-41B2-9FF4-016BBF2B611A}"/>
               </a:ext>
             </a:extLst>
           </p:cNvPr>
@@ -15514,7 +15514,7 @@
           <p:cNvPr id="11" name="Los registros obsoletos pueden volver a utilizarse por error">
             <a:extLst xmlns:a="http://schemas.openxmlformats.org/drawingml/2006/main">
               <a:ext uri="{FF2B5EF4-FFF2-40B4-BE49-F238E27FC236}">
-                <a16:creationId xmlns:a16="http://schemas.microsoft.com/office/drawing/2014/main" id="{DE80B2D1-A8BC-4E22-A92E-1C0FF546C4FA}"/>
+                <a16:creationId xmlns:a16="http://schemas.microsoft.com/office/drawing/2014/main" id="{88D9A875-25F8-4AA7-9D8B-213EEFE5A891}"/>
               </a:ext>
             </a:extLst>
           </p:cNvPr>
@@ -15571,7 +15571,7 @@
           <p:cNvPr id="12" name="Caso ficticio de pyme de transporte definido mediante una en">
             <a:extLst xmlns:a="http://schemas.openxmlformats.org/drawingml/2006/main">
               <a:ext uri="{FF2B5EF4-FFF2-40B4-BE49-F238E27FC236}">
-                <a16:creationId xmlns:a16="http://schemas.microsoft.com/office/drawing/2014/main" id="{A2AF83F1-85D4-4677-AAD0-1BBC84DA3FA7}"/>
+                <a16:creationId xmlns:a16="http://schemas.microsoft.com/office/drawing/2014/main" id="{F5221A09-2364-4672-BD8E-E9705DC11E17}"/>
               </a:ext>
             </a:extLst>
           </p:cNvPr>
@@ -15628,7 +15628,7 @@
           <p:cNvPr id="13" name="Memoria, pp. 1–3 y 15. El trabajo no mide impacto en una emp">
             <a:extLst xmlns:a="http://schemas.openxmlformats.org/drawingml/2006/main">
               <a:ext uri="{FF2B5EF4-FFF2-40B4-BE49-F238E27FC236}">
-                <a16:creationId xmlns:a16="http://schemas.microsoft.com/office/drawing/2014/main" id="{A6E7F284-C9D3-45C2-B29D-CE6DF93C3625}"/>
+                <a16:creationId xmlns:a16="http://schemas.microsoft.com/office/drawing/2014/main" id="{2A90A424-F55F-47B8-B65C-33B9553E7395}"/>
               </a:ext>
             </a:extLst>
           </p:cNvPr>
@@ -15683,7 +15683,7 @@
     </p:spTree>
     <p:extLst>
       <p:ext uri="{BB962C8B-B14F-4D97-AF65-F5344CB8AC3E}">
-        <p14:creationId xmlns:p14="http://schemas.microsoft.com/office/powerpoint/2010/main" val="1305083320"/>
+        <p14:creationId xmlns:p14="http://schemas.microsoft.com/office/powerpoint/2010/main" val="1638030788"/>
       </p:ext>
     </p:extLst>
   </p:cSld>
@@ -15714,7 +15714,7 @@
           <p:cNvPr id="8" name="01 · PROBLEMA Y OBJETIVOS">
             <a:extLst xmlns:a="http://schemas.openxmlformats.org/drawingml/2006/main">
               <a:ext uri="{FF2B5EF4-FFF2-40B4-BE49-F238E27FC236}">
-                <a16:creationId xmlns:a16="http://schemas.microsoft.com/office/drawing/2014/main" id="{45D5332A-355E-46D7-B6F0-0C1940188731}"/>
+                <a16:creationId xmlns:a16="http://schemas.microsoft.com/office/drawing/2014/main" id="{54A7431B-3C2B-4FC6-AF66-592A6699931C}"/>
               </a:ext>
             </a:extLst>
           </p:cNvPr>
@@ -15771,7 +15771,7 @@
           <p:cNvPr id="2" name="Objetivos y criterios de éxito">
             <a:extLst xmlns:a="http://schemas.openxmlformats.org/drawingml/2006/main">
               <a:ext uri="{FF2B5EF4-FFF2-40B4-BE49-F238E27FC236}">
-                <a16:creationId xmlns:a16="http://schemas.microsoft.com/office/drawing/2014/main" id="{7326632D-F9BB-482D-9A82-8C3B5A2A2304}"/>
+                <a16:creationId xmlns:a16="http://schemas.microsoft.com/office/drawing/2014/main" id="{581FA27D-95F0-4877-BE89-C935221CC36E}"/>
               </a:ext>
             </a:extLst>
           </p:cNvPr>
@@ -15828,7 +15828,7 @@
           <p:cNvPr id="3" name="">
             <a:extLst xmlns:a="http://schemas.openxmlformats.org/drawingml/2006/main">
               <a:ext uri="{FF2B5EF4-FFF2-40B4-BE49-F238E27FC236}">
-                <a16:creationId xmlns:a16="http://schemas.microsoft.com/office/drawing/2014/main" id="{DB3B2358-24D4-4BA9-ADBD-56420B65F4A6}"/>
+                <a16:creationId xmlns:a16="http://schemas.microsoft.com/office/drawing/2014/main" id="{413C28AB-1AB3-42E5-9AE1-E54E43724DB0}"/>
               </a:ext>
             </a:extLst>
           </p:cNvPr>
@@ -15858,7 +15858,7 @@
           <p:cNvPr id="4" name="04">
             <a:extLst xmlns:a="http://schemas.openxmlformats.org/drawingml/2006/main">
               <a:ext uri="{FF2B5EF4-FFF2-40B4-BE49-F238E27FC236}">
-                <a16:creationId xmlns:a16="http://schemas.microsoft.com/office/drawing/2014/main" id="{B0EF980F-548E-48A0-9FA9-B97AF8B7A1F5}"/>
+                <a16:creationId xmlns:a16="http://schemas.microsoft.com/office/drawing/2014/main" id="{DFAC8CB6-0B22-421E-8EAE-99D8EAE0E0C4}"/>
               </a:ext>
             </a:extLst>
           </p:cNvPr>
@@ -15915,7 +15915,7 @@
           <p:cNvPr id="5" name="Centralizar la operación diaria y demostrar el ciclo de vida">
             <a:extLst xmlns:a="http://schemas.openxmlformats.org/drawingml/2006/main">
               <a:ext uri="{FF2B5EF4-FFF2-40B4-BE49-F238E27FC236}">
-                <a16:creationId xmlns:a16="http://schemas.microsoft.com/office/drawing/2014/main" id="{90A6A221-0257-471F-8B91-2A195FE9DB4B}"/>
+                <a16:creationId xmlns:a16="http://schemas.microsoft.com/office/drawing/2014/main" id="{92F104CE-12BA-4056-BB51-0C4606D7F089}"/>
               </a:ext>
             </a:extLst>
           </p:cNvPr>
@@ -16264,7 +16264,7 @@
           <p:cNvPr id="7" name="Objetivo general y criterios de éxito de la memoria, pp. 2–3">
             <a:extLst xmlns:a="http://schemas.openxmlformats.org/drawingml/2006/main">
               <a:ext uri="{FF2B5EF4-FFF2-40B4-BE49-F238E27FC236}">
-                <a16:creationId xmlns:a16="http://schemas.microsoft.com/office/drawing/2014/main" id="{A0D2B46C-EFFE-4644-ABE2-E4B9913B438A}"/>
+                <a16:creationId xmlns:a16="http://schemas.microsoft.com/office/drawing/2014/main" id="{DB5634C9-C1D0-4AA7-A964-24B0FA0D64FB}"/>
               </a:ext>
             </a:extLst>
           </p:cNvPr>
@@ -16319,7 +16319,7 @@
     </p:spTree>
     <p:extLst>
       <p:ext uri="{BB962C8B-B14F-4D97-AF65-F5344CB8AC3E}">
-        <p14:creationId xmlns:p14="http://schemas.microsoft.com/office/powerpoint/2010/main" val="1942817062"/>
+        <p14:creationId xmlns:p14="http://schemas.microsoft.com/office/powerpoint/2010/main" val="2141617904"/>
       </p:ext>
     </p:extLst>
   </p:cSld>
@@ -16350,7 +16350,7 @@
           <p:cNvPr id="18" name="02 · REQUISITOS Y ALCANCE">
             <a:extLst xmlns:a="http://schemas.openxmlformats.org/drawingml/2006/main">
               <a:ext uri="{FF2B5EF4-FFF2-40B4-BE49-F238E27FC236}">
-                <a16:creationId xmlns:a16="http://schemas.microsoft.com/office/drawing/2014/main" id="{9EC32E37-A6A0-4D10-9346-4285699E9C0C}"/>
+                <a16:creationId xmlns:a16="http://schemas.microsoft.com/office/drawing/2014/main" id="{9AC4A15D-1C9A-4995-9B5B-D7D4B3E4856C}"/>
               </a:ext>
             </a:extLst>
           </p:cNvPr>
@@ -16407,7 +16407,7 @@
           <p:cNvPr id="2" name="Requisitos y alcance">
             <a:extLst xmlns:a="http://schemas.openxmlformats.org/drawingml/2006/main">
               <a:ext uri="{FF2B5EF4-FFF2-40B4-BE49-F238E27FC236}">
-                <a16:creationId xmlns:a16="http://schemas.microsoft.com/office/drawing/2014/main" id="{B58729C1-6346-492E-A2EE-A2E73E6B2E04}"/>
+                <a16:creationId xmlns:a16="http://schemas.microsoft.com/office/drawing/2014/main" id="{0089DF4C-0C7B-4BDC-997E-A6B693F3DBC7}"/>
               </a:ext>
             </a:extLst>
           </p:cNvPr>
@@ -16464,7 +16464,7 @@
           <p:cNvPr id="3" name="">
             <a:extLst xmlns:a="http://schemas.openxmlformats.org/drawingml/2006/main">
               <a:ext uri="{FF2B5EF4-FFF2-40B4-BE49-F238E27FC236}">
-                <a16:creationId xmlns:a16="http://schemas.microsoft.com/office/drawing/2014/main" id="{CC9E89C2-BA3E-468E-981B-C456448C9A23}"/>
+                <a16:creationId xmlns:a16="http://schemas.microsoft.com/office/drawing/2014/main" id="{E4F0894C-18D2-4458-830D-73578349C3D5}"/>
               </a:ext>
             </a:extLst>
           </p:cNvPr>
@@ -16494,7 +16494,7 @@
           <p:cNvPr id="4" name="05">
             <a:extLst xmlns:a="http://schemas.openxmlformats.org/drawingml/2006/main">
               <a:ext uri="{FF2B5EF4-FFF2-40B4-BE49-F238E27FC236}">
-                <a16:creationId xmlns:a16="http://schemas.microsoft.com/office/drawing/2014/main" id="{EF4EDE32-2276-4400-93D4-C06F316BAD27}"/>
+                <a16:creationId xmlns:a16="http://schemas.microsoft.com/office/drawing/2014/main" id="{AFA4E267-1DF5-49E5-B565-2260A0E608B8}"/>
               </a:ext>
             </a:extLst>
           </p:cNvPr>
@@ -16551,7 +16551,7 @@
           <p:cNvPr id="5" name="14">
             <a:extLst xmlns:a="http://schemas.openxmlformats.org/drawingml/2006/main">
               <a:ext uri="{FF2B5EF4-FFF2-40B4-BE49-F238E27FC236}">
-                <a16:creationId xmlns:a16="http://schemas.microsoft.com/office/drawing/2014/main" id="{82C16979-5013-4C42-9092-1D6C36B27C1B}"/>
+                <a16:creationId xmlns:a16="http://schemas.microsoft.com/office/drawing/2014/main" id="{E4DA2B0D-247C-4EDE-9ABA-17EC78AFC99C}"/>
               </a:ext>
             </a:extLst>
           </p:cNvPr>
@@ -16608,7 +16608,7 @@
           <p:cNvPr id="6" name="requisitos&#10;funcionales">
             <a:extLst xmlns:a="http://schemas.openxmlformats.org/drawingml/2006/main">
               <a:ext uri="{FF2B5EF4-FFF2-40B4-BE49-F238E27FC236}">
-                <a16:creationId xmlns:a16="http://schemas.microsoft.com/office/drawing/2014/main" id="{4FDEE55D-8B48-41D6-BF4C-D3BEE592368E}"/>
+                <a16:creationId xmlns:a16="http://schemas.microsoft.com/office/drawing/2014/main" id="{96454C64-7F0B-4AA6-84AA-6F8EC92EB09F}"/>
               </a:ext>
             </a:extLst>
           </p:cNvPr>
@@ -16688,7 +16688,7 @@
           <p:cNvPr id="7" name="17">
             <a:extLst xmlns:a="http://schemas.openxmlformats.org/drawingml/2006/main">
               <a:ext uri="{FF2B5EF4-FFF2-40B4-BE49-F238E27FC236}">
-                <a16:creationId xmlns:a16="http://schemas.microsoft.com/office/drawing/2014/main" id="{19B5863C-4B00-40B3-BA6F-87799AD1FB79}"/>
+                <a16:creationId xmlns:a16="http://schemas.microsoft.com/office/drawing/2014/main" id="{0700FE50-1F8B-4A80-A5AC-E93D8D6ADF90}"/>
               </a:ext>
             </a:extLst>
           </p:cNvPr>
@@ -16745,7 +16745,7 @@
           <p:cNvPr id="8" name="reglas de&#10;negocio">
             <a:extLst xmlns:a="http://schemas.openxmlformats.org/drawingml/2006/main">
               <a:ext uri="{FF2B5EF4-FFF2-40B4-BE49-F238E27FC236}">
-                <a16:creationId xmlns:a16="http://schemas.microsoft.com/office/drawing/2014/main" id="{0861E509-38AE-4664-B38F-71DEA912D34A}"/>
+                <a16:creationId xmlns:a16="http://schemas.microsoft.com/office/drawing/2014/main" id="{8814CEFB-09EE-473D-A137-E9A8136EDC46}"/>
               </a:ext>
             </a:extLst>
           </p:cNvPr>
@@ -16825,7 +16825,7 @@
           <p:cNvPr id="9" name="6">
             <a:extLst xmlns:a="http://schemas.openxmlformats.org/drawingml/2006/main">
               <a:ext uri="{FF2B5EF4-FFF2-40B4-BE49-F238E27FC236}">
-                <a16:creationId xmlns:a16="http://schemas.microsoft.com/office/drawing/2014/main" id="{08F81C91-70E7-4663-B6AA-3F27A00AAE29}"/>
+                <a16:creationId xmlns:a16="http://schemas.microsoft.com/office/drawing/2014/main" id="{6D8C2BE0-15AC-46B4-AA8C-7FF99153328E}"/>
               </a:ext>
             </a:extLst>
           </p:cNvPr>
@@ -16882,7 +16882,7 @@
           <p:cNvPr id="10" name="requisitos no&#10;funcionales">
             <a:extLst xmlns:a="http://schemas.openxmlformats.org/drawingml/2006/main">
               <a:ext uri="{FF2B5EF4-FFF2-40B4-BE49-F238E27FC236}">
-                <a16:creationId xmlns:a16="http://schemas.microsoft.com/office/drawing/2014/main" id="{47EE636E-E6FB-49DF-A0F2-60976260F2E4}"/>
+                <a16:creationId xmlns:a16="http://schemas.microsoft.com/office/drawing/2014/main" id="{A218D201-39AA-454F-972B-44F6D5D84A97}"/>
               </a:ext>
             </a:extLst>
           </p:cNvPr>
@@ -16962,7 +16962,7 @@
           <p:cNvPr id="11" name="Incluido">
             <a:extLst xmlns:a="http://schemas.openxmlformats.org/drawingml/2006/main">
               <a:ext uri="{FF2B5EF4-FFF2-40B4-BE49-F238E27FC236}">
-                <a16:creationId xmlns:a16="http://schemas.microsoft.com/office/drawing/2014/main" id="{5138CC96-0C68-47CF-A823-366176CFFC0E}"/>
+                <a16:creationId xmlns:a16="http://schemas.microsoft.com/office/drawing/2014/main" id="{450780EC-F11E-4E95-A2C6-E74E0F2F8FAE}"/>
               </a:ext>
             </a:extLst>
           </p:cNvPr>
@@ -17019,7 +17019,7 @@
           <p:cNvPr id="12" name="Catálogos y envíos&#10;Asignación y estados&#10;Eventos e incidencia">
             <a:extLst xmlns:a="http://schemas.openxmlformats.org/drawingml/2006/main">
               <a:ext uri="{FF2B5EF4-FFF2-40B4-BE49-F238E27FC236}">
-                <a16:creationId xmlns:a16="http://schemas.microsoft.com/office/drawing/2014/main" id="{648DFA47-312A-492D-A54A-BB3B623C9B36}"/>
+                <a16:creationId xmlns:a16="http://schemas.microsoft.com/office/drawing/2014/main" id="{E9431014-63BD-444A-BD1D-487BA67E30C8}"/>
               </a:ext>
             </a:extLst>
           </p:cNvPr>
@@ -17145,7 +17145,7 @@
           <p:cNvPr id="13" name="Fuera del TFG">
             <a:extLst xmlns:a="http://schemas.openxmlformats.org/drawingml/2006/main">
               <a:ext uri="{FF2B5EF4-FFF2-40B4-BE49-F238E27FC236}">
-                <a16:creationId xmlns:a16="http://schemas.microsoft.com/office/drawing/2014/main" id="{936C7A32-BAB6-4E18-95A2-E354395C13A3}"/>
+                <a16:creationId xmlns:a16="http://schemas.microsoft.com/office/drawing/2014/main" id="{206ACEA6-B323-473E-9770-402761AA7D14}"/>
               </a:ext>
             </a:extLst>
           </p:cNvPr>
@@ -17202,7 +17202,7 @@
           <p:cNvPr id="14" name="Optimización de rutas&#10;GPS y facturación&#10;Acceso de clientes e">
             <a:extLst xmlns:a="http://schemas.openxmlformats.org/drawingml/2006/main">
               <a:ext uri="{FF2B5EF4-FFF2-40B4-BE49-F238E27FC236}">
-                <a16:creationId xmlns:a16="http://schemas.microsoft.com/office/drawing/2014/main" id="{EBD14E07-BB9D-474E-8CF0-F043E9992CB4}"/>
+                <a16:creationId xmlns:a16="http://schemas.microsoft.com/office/drawing/2014/main" id="{0B3E0D1C-87E5-4019-80B7-D731D3165923}"/>
               </a:ext>
             </a:extLst>
           </p:cNvPr>
@@ -17305,7 +17305,7 @@
           <p:cNvPr id="15" name="Actores del sistema">
             <a:extLst xmlns:a="http://schemas.openxmlformats.org/drawingml/2006/main">
               <a:ext uri="{FF2B5EF4-FFF2-40B4-BE49-F238E27FC236}">
-                <a16:creationId xmlns:a16="http://schemas.microsoft.com/office/drawing/2014/main" id="{C128A152-2C95-40AC-9E08-40B75AAE7434}"/>
+                <a16:creationId xmlns:a16="http://schemas.microsoft.com/office/drawing/2014/main" id="{5DF9C886-D4CC-47D7-8E5C-A286500FA085}"/>
               </a:ext>
             </a:extLst>
           </p:cNvPr>
@@ -17362,7 +17362,7 @@
           <p:cNvPr id="16" name="Operador: trabajo diario&#10;Administrador: cuentas y permisos">
             <a:extLst xmlns:a="http://schemas.openxmlformats.org/drawingml/2006/main">
               <a:ext uri="{FF2B5EF4-FFF2-40B4-BE49-F238E27FC236}">
-                <a16:creationId xmlns:a16="http://schemas.microsoft.com/office/drawing/2014/main" id="{57AE949B-F2F5-496F-AF06-5F9B4219A963}"/>
+                <a16:creationId xmlns:a16="http://schemas.microsoft.com/office/drawing/2014/main" id="{4E946258-9ABF-453D-960D-2E333C0F9D63}"/>
               </a:ext>
             </a:extLst>
           </p:cNvPr>
@@ -17442,7 +17442,7 @@
           <p:cNvPr id="17" name="Conductores y clientes son datos del dominio. Memoria, pp. 1">
             <a:extLst xmlns:a="http://schemas.openxmlformats.org/drawingml/2006/main">
               <a:ext uri="{FF2B5EF4-FFF2-40B4-BE49-F238E27FC236}">
-                <a16:creationId xmlns:a16="http://schemas.microsoft.com/office/drawing/2014/main" id="{61F493CE-C079-462E-813D-DA96B0FFBF7D}"/>
+                <a16:creationId xmlns:a16="http://schemas.microsoft.com/office/drawing/2014/main" id="{F72F67DF-EAB1-47DE-99BB-E4FCC42443F1}"/>
               </a:ext>
             </a:extLst>
           </p:cNvPr>
@@ -17497,7 +17497,7 @@
     </p:spTree>
     <p:extLst>
       <p:ext uri="{BB962C8B-B14F-4D97-AF65-F5344CB8AC3E}">
-        <p14:creationId xmlns:p14="http://schemas.microsoft.com/office/powerpoint/2010/main" val="994013194"/>
+        <p14:creationId xmlns:p14="http://schemas.microsoft.com/office/powerpoint/2010/main" val="1771680238"/>
       </p:ext>
     </p:extLst>
   </p:cSld>
@@ -17528,7 +17528,7 @@
           <p:cNvPr id="7" name="02 · REQUISITOS Y ALCANCE">
             <a:extLst xmlns:a="http://schemas.openxmlformats.org/drawingml/2006/main">
               <a:ext uri="{FF2B5EF4-FFF2-40B4-BE49-F238E27FC236}">
-                <a16:creationId xmlns:a16="http://schemas.microsoft.com/office/drawing/2014/main" id="{57EB2A22-B187-41F6-B309-81759F665577}"/>
+                <a16:creationId xmlns:a16="http://schemas.microsoft.com/office/drawing/2014/main" id="{D851014D-0FA7-430C-AD1C-E6C925BB53EB}"/>
               </a:ext>
             </a:extLst>
           </p:cNvPr>
@@ -17582,10 +17582,10 @@
       </p:sp>
       <p:sp>
         <p:nvSpPr>
-          <p:cNvPr id="2" name="Casos de uso del sistema">
-            <a:extLst xmlns:a="http://schemas.openxmlformats.org/drawingml/2006/main">
-              <a:ext uri="{FF2B5EF4-FFF2-40B4-BE49-F238E27FC236}">
-                <a16:creationId xmlns:a16="http://schemas.microsoft.com/office/drawing/2014/main" id="{739750F0-20A1-4782-AAA0-FB6591798906}"/>
+          <p:cNvPr id="2" name="Casos de uso definidos en la memoria">
+            <a:extLst xmlns:a="http://schemas.openxmlformats.org/drawingml/2006/main">
+              <a:ext uri="{FF2B5EF4-FFF2-40B4-BE49-F238E27FC236}">
+                <a16:creationId xmlns:a16="http://schemas.microsoft.com/office/drawing/2014/main" id="{374E3853-A5AA-4180-900B-514635755DE8}"/>
               </a:ext>
             </a:extLst>
           </p:cNvPr>
@@ -17632,7 +17632,7 @@
                 <a:ea typeface="Arial"/>
                 <a:cs typeface="Arial"/>
               </a:rPr>
-              <a:t>Casos de uso del sistema</a:t>
+              <a:t>Casos de uso definidos en la memoria</a:t>
             </a:r>
           </a:p>
         </p:txBody>
@@ -17642,7 +17642,7 @@
           <p:cNvPr id="3" name="">
             <a:extLst xmlns:a="http://schemas.openxmlformats.org/drawingml/2006/main">
               <a:ext uri="{FF2B5EF4-FFF2-40B4-BE49-F238E27FC236}">
-                <a16:creationId xmlns:a16="http://schemas.microsoft.com/office/drawing/2014/main" id="{BA14A290-7DDA-47FF-B4D0-A2E2B20BB6C0}"/>
+                <a16:creationId xmlns:a16="http://schemas.microsoft.com/office/drawing/2014/main" id="{8E19D6D9-618B-435A-9234-19E45B1B143C}"/>
               </a:ext>
             </a:extLst>
           </p:cNvPr>
@@ -17672,7 +17672,7 @@
           <p:cNvPr id="4" name="06">
             <a:extLst xmlns:a="http://schemas.openxmlformats.org/drawingml/2006/main">
               <a:ext uri="{FF2B5EF4-FFF2-40B4-BE49-F238E27FC236}">
-                <a16:creationId xmlns:a16="http://schemas.microsoft.com/office/drawing/2014/main" id="{46AE2BA6-802F-4588-B148-55756E30D498}"/>
+                <a16:creationId xmlns:a16="http://schemas.microsoft.com/office/drawing/2014/main" id="{92977D1D-5511-4982-84BA-D0BD7D7FF01B}"/>
               </a:ext>
             </a:extLst>
           </p:cNvPr>
@@ -17731,19 +17731,19 @@
           <p:nvPr/>
         </p:nvGraphicFramePr>
         <p:xfrm>
-          <a:off xmlns:a="http://schemas.openxmlformats.org/drawingml/2006/main" x="609600" y="1695450"/>
-          <a:ext xmlns:a="http://schemas.openxmlformats.org/drawingml/2006/main" cx="10972800" cy="4095750"/>
+          <a:off xmlns:a="http://schemas.openxmlformats.org/drawingml/2006/main" x="609600" y="1619250"/>
+          <a:ext xmlns:a="http://schemas.openxmlformats.org/drawingml/2006/main" cx="10972800" cy="4248150"/>
         </p:xfrm>
         <a:graphic xmlns:a="http://schemas.openxmlformats.org/drawingml/2006/main">
           <a:graphicData uri="http://schemas.openxmlformats.org/drawingml/2006/table">
             <a:tbl>
               <a:tblPr firstRow="0" bandRow="0"/>
               <a:tblGrid>
-                <a:gridCol w="3000375"/>
-                <a:gridCol w="2952750"/>
-                <a:gridCol w="5019675"/>
+                <a:gridCol w="3571875"/>
+                <a:gridCol w="3333750"/>
+                <a:gridCol w="4067175"/>
               </a:tblGrid>
-              <a:tr h="819150">
+              <a:tr h="849630">
                 <a:tc>
                   <a:txBody>
                     <a:bodyPr>
@@ -17752,7 +17752,7 @@
                     <a:lstStyle/>
                     <a:p>
                       <a:r>
-                        <a:rPr sz="1725" b="1">
+                        <a:rPr sz="1425" b="1">
                           <a:solidFill>
                             <a:srgbClr val="FFFFFF"/>
                           </a:solidFill>
@@ -17778,7 +17778,7 @@
                     <a:lstStyle/>
                     <a:p>
                       <a:r>
-                        <a:rPr sz="1725" b="1">
+                        <a:rPr sz="1425" b="1">
                           <a:solidFill>
                             <a:srgbClr val="FFFFFF"/>
                           </a:solidFill>
@@ -17786,7 +17786,7 @@
                           <a:ea typeface="Arial"/>
                           <a:cs typeface="Arial"/>
                         </a:rPr>
-                        <a:t>Actor principal</a:t>
+                        <a:t>Actor y responsabilidad</a:t>
                       </a:r>
                     </a:p>
                   </a:txBody>
@@ -17804,7 +17804,7 @@
                     <a:lstStyle/>
                     <a:p>
                       <a:r>
-                        <a:rPr sz="1725" b="1">
+                        <a:rPr sz="1425" b="1">
                           <a:solidFill>
                             <a:srgbClr val="FFFFFF"/>
                           </a:solidFill>
@@ -17823,7 +17823,7 @@
                   </a:tcPr>
                 </a:tc>
               </a:tr>
-              <a:tr h="819150">
+              <a:tr h="849630">
                 <a:tc>
                   <a:txBody>
                     <a:bodyPr>
@@ -17832,7 +17832,7 @@
                     <a:lstStyle/>
                     <a:p>
                       <a:r>
-                        <a:rPr sz="1725" b="0">
+                        <a:rPr sz="1425" b="0">
                           <a:solidFill>
                             <a:srgbClr val="14263D"/>
                           </a:solidFill>
@@ -17840,7 +17840,7 @@
                           <a:ea typeface="Arial"/>
                           <a:cs typeface="Arial"/>
                         </a:rPr>
-                        <a:t>Acceso y sesión</a:t>
+                        <a:t>CU-1 · Poner en marcha una instalación vacía</a:t>
                       </a:r>
                     </a:p>
                   </a:txBody>
@@ -17858,7 +17858,7 @@
                     <a:lstStyle/>
                     <a:p>
                       <a:r>
-                        <a:rPr sz="1725" b="0">
+                        <a:rPr sz="1425" b="0">
                           <a:solidFill>
                             <a:srgbClr val="14263D"/>
                           </a:solidFill>
@@ -17866,7 +17866,7 @@
                           <a:ea typeface="Arial"/>
                           <a:cs typeface="Arial"/>
                         </a:rPr>
-                        <a:t>Operador / administrador</a:t>
+                        <a:t>Instalador</a:t>
                       </a:r>
                     </a:p>
                   </a:txBody>
@@ -17884,7 +17884,7 @@
                     <a:lstStyle/>
                     <a:p>
                       <a:r>
-                        <a:rPr sz="1725" b="0">
+                        <a:rPr sz="1425" b="0">
                           <a:solidFill>
                             <a:srgbClr val="14263D"/>
                           </a:solidFill>
@@ -17892,7 +17892,7 @@
                           <a:ea typeface="Arial"/>
                           <a:cs typeface="Arial"/>
                         </a:rPr>
-                        <a:t>Entrada segura y permisos efectivos</a:t>
+                        <a:t>Primer administrador creado; arranque bloqueado</a:t>
                       </a:r>
                     </a:p>
                   </a:txBody>
@@ -17903,7 +17903,7 @@
                   </a:tcPr>
                 </a:tc>
               </a:tr>
-              <a:tr h="819150">
+              <a:tr h="849630">
                 <a:tc>
                   <a:txBody>
                     <a:bodyPr>
@@ -17912,7 +17912,7 @@
                     <a:lstStyle/>
                     <a:p>
                       <a:r>
-                        <a:rPr sz="1725" b="0">
+                        <a:rPr sz="1425" b="0">
                           <a:solidFill>
                             <a:srgbClr val="14263D"/>
                           </a:solidFill>
@@ -17920,7 +17920,7 @@
                           <a:ea typeface="Arial"/>
                           <a:cs typeface="Arial"/>
                         </a:rPr>
-                        <a:t>Catálogos</a:t>
+                        <a:t>CU-2 · Incorporar a una persona al sistema</a:t>
                       </a:r>
                     </a:p>
                   </a:txBody>
@@ -17938,7 +17938,100 @@
                     <a:lstStyle/>
                     <a:p>
                       <a:r>
-                        <a:rPr sz="1725" b="0">
+                        <a:rPr sz="1425" b="0">
+                          <a:solidFill>
+                            <a:srgbClr val="14263D"/>
+                          </a:solidFill>
+                          <a:latin typeface="Arial"/>
+                          <a:ea typeface="Arial"/>
+                          <a:cs typeface="Arial"/>
+                        </a:rPr>
+                        <a:t>Administrador: crea la cuenta</a:t>
+                      </a:r>
+                    </a:p>
+                    <a:p>
+                      <a:r>
+                        <a:rPr sz="1425" b="0">
+                          <a:solidFill>
+                            <a:srgbClr val="14263D"/>
+                          </a:solidFill>
+                          <a:latin typeface="Arial"/>
+                          <a:ea typeface="Arial"/>
+                          <a:cs typeface="Arial"/>
+                        </a:rPr>
+                        <a:t>Operador: realiza el primer acceso</a:t>
+                      </a:r>
+                    </a:p>
+                  </a:txBody>
+                  <a:tcPr marL="142875" marR="142875" marT="95250" marB="85725" anchor="ctr">
+                    <a:solidFill>
+                      <a:srgbClr val="FFFFFF"/>
+                    </a:solidFill>
+                  </a:tcPr>
+                </a:tc>
+                <a:tc>
+                  <a:txBody>
+                    <a:bodyPr>
+                      <a:noAutofit/>
+                    </a:bodyPr>
+                    <a:lstStyle/>
+                    <a:p>
+                      <a:r>
+                        <a:rPr sz="1425" b="0">
+                          <a:solidFill>
+                            <a:srgbClr val="14263D"/>
+                          </a:solidFill>
+                          <a:latin typeface="Arial"/>
+                          <a:ea typeface="Arial"/>
+                          <a:cs typeface="Arial"/>
+                        </a:rPr>
+                        <a:t>Cuenta activa con contraseña propia</a:t>
+                      </a:r>
+                    </a:p>
+                  </a:txBody>
+                  <a:tcPr marL="142875" marR="142875" marT="95250" marB="85725" anchor="ctr">
+                    <a:solidFill>
+                      <a:srgbClr val="FFFFFF"/>
+                    </a:solidFill>
+                  </a:tcPr>
+                </a:tc>
+              </a:tr>
+              <a:tr h="849630">
+                <a:tc>
+                  <a:txBody>
+                    <a:bodyPr>
+                      <a:noAutofit/>
+                    </a:bodyPr>
+                    <a:lstStyle/>
+                    <a:p>
+                      <a:r>
+                        <a:rPr sz="1425" b="0">
+                          <a:solidFill>
+                            <a:srgbClr val="14263D"/>
+                          </a:solidFill>
+                          <a:latin typeface="Arial"/>
+                          <a:ea typeface="Arial"/>
+                          <a:cs typeface="Arial"/>
+                        </a:rPr>
+                        <a:t>CU-3 · Ejecutar un envío de principio a fin</a:t>
+                      </a:r>
+                    </a:p>
+                  </a:txBody>
+                  <a:tcPr marL="142875" marR="142875" marT="95250" marB="85725" anchor="ctr">
+                    <a:solidFill>
+                      <a:srgbClr val="FFFFFF"/>
+                    </a:solidFill>
+                  </a:tcPr>
+                </a:tc>
+                <a:tc>
+                  <a:txBody>
+                    <a:bodyPr>
+                      <a:noAutofit/>
+                    </a:bodyPr>
+                    <a:lstStyle/>
+                    <a:p>
+                      <a:r>
+                        <a:rPr sz="1425" b="0">
                           <a:solidFill>
                             <a:srgbClr val="14263D"/>
                           </a:solidFill>
@@ -17964,7 +18057,7 @@
                     <a:lstStyle/>
                     <a:p>
                       <a:r>
-                        <a:rPr sz="1725" b="0">
+                        <a:rPr sz="1425" b="0">
                           <a:solidFill>
                             <a:srgbClr val="14263D"/>
                           </a:solidFill>
@@ -17972,7 +18065,7 @@
                           <a:ea typeface="Arial"/>
                           <a:cs typeface="Arial"/>
                         </a:rPr>
-                        <a:t>Vehículos, conductores y clientes vigentes</a:t>
+                        <a:t>Envío terminal con cronología verificable</a:t>
                       </a:r>
                     </a:p>
                   </a:txBody>
@@ -17983,7 +18076,7 @@
                   </a:tcPr>
                 </a:tc>
               </a:tr>
-              <a:tr h="819150">
+              <a:tr h="849630">
                 <a:tc>
                   <a:txBody>
                     <a:bodyPr>
@@ -17992,7 +18085,7 @@
                     <a:lstStyle/>
                     <a:p>
                       <a:r>
-                        <a:rPr sz="1725" b="0">
+                        <a:rPr sz="1425" b="0">
                           <a:solidFill>
                             <a:srgbClr val="14263D"/>
                           </a:solidFill>
@@ -18000,7 +18093,7 @@
                           <a:ea typeface="Arial"/>
                           <a:cs typeface="Arial"/>
                         </a:rPr>
-                        <a:t>Operación del envío</a:t>
+                        <a:t>CU-4 · Retirar el acceso sin perder historial</a:t>
                       </a:r>
                     </a:p>
                   </a:txBody>
@@ -18018,7 +18111,7 @@
                     <a:lstStyle/>
                     <a:p>
                       <a:r>
-                        <a:rPr sz="1725" b="0">
+                        <a:rPr sz="1425" b="0">
                           <a:solidFill>
                             <a:srgbClr val="14263D"/>
                           </a:solidFill>
@@ -18026,7 +18119,7 @@
                           <a:ea typeface="Arial"/>
                           <a:cs typeface="Arial"/>
                         </a:rPr>
-                        <a:t>Operador</a:t>
+                        <a:t>Administrador</a:t>
                       </a:r>
                     </a:p>
                   </a:txBody>
@@ -18044,7 +18137,7 @@
                     <a:lstStyle/>
                     <a:p>
                       <a:r>
-                        <a:rPr sz="1725" b="0">
+                        <a:rPr sz="1425" b="0">
                           <a:solidFill>
                             <a:srgbClr val="14263D"/>
                           </a:solidFill>
@@ -18052,87 +18145,7 @@
                           <a:ea typeface="Arial"/>
                           <a:cs typeface="Arial"/>
                         </a:rPr>
-                        <a:t>Planificación, asignación, estados y eventos</a:t>
-                      </a:r>
-                    </a:p>
-                  </a:txBody>
-                  <a:tcPr marL="142875" marR="142875" marT="95250" marB="85725" anchor="ctr">
-                    <a:solidFill>
-                      <a:srgbClr val="FFFFFF"/>
-                    </a:solidFill>
-                  </a:tcPr>
-                </a:tc>
-              </a:tr>
-              <a:tr h="819150">
-                <a:tc>
-                  <a:txBody>
-                    <a:bodyPr>
-                      <a:noAutofit/>
-                    </a:bodyPr>
-                    <a:lstStyle/>
-                    <a:p>
-                      <a:r>
-                        <a:rPr sz="1725" b="0">
-                          <a:solidFill>
-                            <a:srgbClr val="14263D"/>
-                          </a:solidFill>
-                          <a:latin typeface="Arial"/>
-                          <a:ea typeface="Arial"/>
-                          <a:cs typeface="Arial"/>
-                        </a:rPr>
-                        <a:t>Administración y resumen</a:t>
-                      </a:r>
-                    </a:p>
-                  </a:txBody>
-                  <a:tcPr marL="142875" marR="142875" marT="95250" marB="85725" anchor="ctr">
-                    <a:solidFill>
-                      <a:srgbClr val="FFFFFF"/>
-                    </a:solidFill>
-                  </a:tcPr>
-                </a:tc>
-                <a:tc>
-                  <a:txBody>
-                    <a:bodyPr>
-                      <a:noAutofit/>
-                    </a:bodyPr>
-                    <a:lstStyle/>
-                    <a:p>
-                      <a:r>
-                        <a:rPr sz="1725" b="0">
-                          <a:solidFill>
-                            <a:srgbClr val="14263D"/>
-                          </a:solidFill>
-                          <a:latin typeface="Arial"/>
-                          <a:ea typeface="Arial"/>
-                          <a:cs typeface="Arial"/>
-                        </a:rPr>
-                        <a:t>Administrador / operador</a:t>
-                      </a:r>
-                    </a:p>
-                  </a:txBody>
-                  <a:tcPr marL="142875" marR="142875" marT="95250" marB="85725" anchor="ctr">
-                    <a:solidFill>
-                      <a:srgbClr val="FFFFFF"/>
-                    </a:solidFill>
-                  </a:tcPr>
-                </a:tc>
-                <a:tc>
-                  <a:txBody>
-                    <a:bodyPr>
-                      <a:noAutofit/>
-                    </a:bodyPr>
-                    <a:lstStyle/>
-                    <a:p>
-                      <a:r>
-                        <a:rPr sz="1725" b="0">
-                          <a:solidFill>
-                            <a:srgbClr val="14263D"/>
-                          </a:solidFill>
-                          <a:latin typeface="Arial"/>
-                          <a:ea typeface="Arial"/>
-                          <a:cs typeface="Arial"/>
-                        </a:rPr>
-                        <a:t>Cuentas controladas e indicadores operativos</a:t>
+                        <a:t>Cuenta desactivada; historial conservado</a:t>
                       </a:r>
                     </a:p>
                   </a:txBody>
@@ -18149,10 +18162,10 @@
       </p:graphicFrame>
       <p:sp>
         <p:nvSpPr>
-          <p:cNvPr id="6" name="Los cuatro recorridos definen el alcance integrado y las pru">
-            <a:extLst xmlns:a="http://schemas.openxmlformats.org/drawingml/2006/main">
-              <a:ext uri="{FF2B5EF4-FFF2-40B4-BE49-F238E27FC236}">
-                <a16:creationId xmlns:a16="http://schemas.microsoft.com/office/drawing/2014/main" id="{F58A6BB6-4E10-42F6-86D4-4B9B4663689C}"/>
+          <p:cNvPr id="6" name="Operador y administrador son roles separados; en CU-2 interv">
+            <a:extLst xmlns:a="http://schemas.openxmlformats.org/drawingml/2006/main">
+              <a:ext uri="{FF2B5EF4-FFF2-40B4-BE49-F238E27FC236}">
+                <a16:creationId xmlns:a16="http://schemas.microsoft.com/office/drawing/2014/main" id="{780534DC-C4AD-4E99-ABE8-247FD7E72231}"/>
               </a:ext>
             </a:extLst>
           </p:cNvPr>
@@ -18199,7 +18212,7 @@
                 <a:ea typeface="Arial"/>
                 <a:cs typeface="Arial"/>
               </a:rPr>
-              <a:t>Los cuatro recorridos definen el alcance integrado y las pruebas de sistema. Memoria, pp. 17–21.</a:t>
+              <a:t>Operador y administrador son roles separados; en CU-2 intervienen en momentos distintos. Memoria, pp. 17–21.</a:t>
             </a:r>
           </a:p>
         </p:txBody>
@@ -18207,7 +18220,7 @@
     </p:spTree>
     <p:extLst>
       <p:ext uri="{BB962C8B-B14F-4D97-AF65-F5344CB8AC3E}">
-        <p14:creationId xmlns:p14="http://schemas.microsoft.com/office/powerpoint/2010/main" val="864456950"/>
+        <p14:creationId xmlns:p14="http://schemas.microsoft.com/office/powerpoint/2010/main" val="1340239283"/>
       </p:ext>
     </p:extLst>
   </p:cSld>
@@ -18238,7 +18251,7 @@
           <p:cNvPr id="11" name="03 · METODOLOGÍA">
             <a:extLst xmlns:a="http://schemas.openxmlformats.org/drawingml/2006/main">
               <a:ext uri="{FF2B5EF4-FFF2-40B4-BE49-F238E27FC236}">
-                <a16:creationId xmlns:a16="http://schemas.microsoft.com/office/drawing/2014/main" id="{FF07A48E-6D16-4CD4-8B97-1784C61FC05F}"/>
+                <a16:creationId xmlns:a16="http://schemas.microsoft.com/office/drawing/2014/main" id="{AF51C92A-F26A-4D7B-98A0-69790A35D449}"/>
               </a:ext>
             </a:extLst>
           </p:cNvPr>
@@ -18295,7 +18308,7 @@
           <p:cNvPr id="2" name="Metodología incremental">
             <a:extLst xmlns:a="http://schemas.openxmlformats.org/drawingml/2006/main">
               <a:ext uri="{FF2B5EF4-FFF2-40B4-BE49-F238E27FC236}">
-                <a16:creationId xmlns:a16="http://schemas.microsoft.com/office/drawing/2014/main" id="{DD4ABDEB-8183-4423-AD14-0FC086E9D3E8}"/>
+                <a16:creationId xmlns:a16="http://schemas.microsoft.com/office/drawing/2014/main" id="{9DEBC868-7E30-4F9D-941C-B2CA2C817ED1}"/>
               </a:ext>
             </a:extLst>
           </p:cNvPr>
@@ -18352,7 +18365,7 @@
           <p:cNvPr id="3" name="">
             <a:extLst xmlns:a="http://schemas.openxmlformats.org/drawingml/2006/main">
               <a:ext uri="{FF2B5EF4-FFF2-40B4-BE49-F238E27FC236}">
-                <a16:creationId xmlns:a16="http://schemas.microsoft.com/office/drawing/2014/main" id="{665BAFA1-61EB-4635-9833-1F7349490180}"/>
+                <a16:creationId xmlns:a16="http://schemas.microsoft.com/office/drawing/2014/main" id="{A1D0413F-D3B2-4314-9C92-20D3416E1196}"/>
               </a:ext>
             </a:extLst>
           </p:cNvPr>
@@ -18382,7 +18395,7 @@
           <p:cNvPr id="4" name="07">
             <a:extLst xmlns:a="http://schemas.openxmlformats.org/drawingml/2006/main">
               <a:ext uri="{FF2B5EF4-FFF2-40B4-BE49-F238E27FC236}">
-                <a16:creationId xmlns:a16="http://schemas.microsoft.com/office/drawing/2014/main" id="{2B42D15A-EBC0-49BE-8D03-AD9D0D37ED02}"/>
+                <a16:creationId xmlns:a16="http://schemas.microsoft.com/office/drawing/2014/main" id="{445D49EB-C7D3-4209-837F-F8A7471296B2}"/>
               </a:ext>
             </a:extLst>
           </p:cNvPr>
@@ -18785,7 +18798,7 @@
           <p:cNvPr id="6" name="Definición de hecho">
             <a:extLst xmlns:a="http://schemas.openxmlformats.org/drawingml/2006/main">
               <a:ext uri="{FF2B5EF4-FFF2-40B4-BE49-F238E27FC236}">
-                <a16:creationId xmlns:a16="http://schemas.microsoft.com/office/drawing/2014/main" id="{D32FCEF4-4B8B-4B16-A28D-B52D93CD9178}"/>
+                <a16:creationId xmlns:a16="http://schemas.microsoft.com/office/drawing/2014/main" id="{A6444D47-E177-4834-B58A-8304FEA87C1A}"/>
               </a:ext>
             </a:extLst>
           </p:cNvPr>
@@ -18842,7 +18855,7 @@
           <p:cNvPr id="7" name="Flujo utilizable&#10;Pruebas y compilación&#10;Evidencia documentada">
             <a:extLst xmlns:a="http://schemas.openxmlformats.org/drawingml/2006/main">
               <a:ext uri="{FF2B5EF4-FFF2-40B4-BE49-F238E27FC236}">
-                <a16:creationId xmlns:a16="http://schemas.microsoft.com/office/drawing/2014/main" id="{7EA85B2E-E66F-48BC-AE8B-DC92FE6390E7}"/>
+                <a16:creationId xmlns:a16="http://schemas.microsoft.com/office/drawing/2014/main" id="{9C099FFE-A487-4349-9AF9-575E89BFFB66}"/>
               </a:ext>
             </a:extLst>
           </p:cNvPr>
@@ -18945,7 +18958,7 @@
           <p:cNvPr id="8" name="Decisión de diseño">
             <a:extLst xmlns:a="http://schemas.openxmlformats.org/drawingml/2006/main">
               <a:ext uri="{FF2B5EF4-FFF2-40B4-BE49-F238E27FC236}">
-                <a16:creationId xmlns:a16="http://schemas.microsoft.com/office/drawing/2014/main" id="{BFB6B1EB-70DA-4E93-B5DD-C40093474BD5}"/>
+                <a16:creationId xmlns:a16="http://schemas.microsoft.com/office/drawing/2014/main" id="{82D41AEE-3576-40CC-945D-130C557E1000}"/>
               </a:ext>
             </a:extLst>
           </p:cNvPr>
@@ -19002,7 +19015,7 @@
           <p:cNvPr id="9" name="Modelo conceptual completo&#10;y esquema físico incremental">
             <a:extLst xmlns:a="http://schemas.openxmlformats.org/drawingml/2006/main">
               <a:ext uri="{FF2B5EF4-FFF2-40B4-BE49-F238E27FC236}">
-                <a16:creationId xmlns:a16="http://schemas.microsoft.com/office/drawing/2014/main" id="{432D82EB-6A87-4FD8-96DF-8F3EFBC844DF}"/>
+                <a16:creationId xmlns:a16="http://schemas.microsoft.com/office/drawing/2014/main" id="{1FB08AD8-008C-4CD9-92CE-7B795AEAB439}"/>
               </a:ext>
             </a:extLst>
           </p:cNvPr>
@@ -19082,7 +19095,7 @@
           <p:cNvPr id="10" name="Rebanadas verticales adaptadas a un proyecto individual. Mem">
             <a:extLst xmlns:a="http://schemas.openxmlformats.org/drawingml/2006/main">
               <a:ext uri="{FF2B5EF4-FFF2-40B4-BE49-F238E27FC236}">
-                <a16:creationId xmlns:a16="http://schemas.microsoft.com/office/drawing/2014/main" id="{440DDFC9-AB21-4708-98CB-86B4AF2E3D23}"/>
+                <a16:creationId xmlns:a16="http://schemas.microsoft.com/office/drawing/2014/main" id="{8B97E3BE-6693-4238-A673-EA8B7D02C31B}"/>
               </a:ext>
             </a:extLst>
           </p:cNvPr>
@@ -19137,7 +19150,7 @@
     </p:spTree>
     <p:extLst>
       <p:ext uri="{BB962C8B-B14F-4D97-AF65-F5344CB8AC3E}">
-        <p14:creationId xmlns:p14="http://schemas.microsoft.com/office/powerpoint/2010/main" val="1401547701"/>
+        <p14:creationId xmlns:p14="http://schemas.microsoft.com/office/powerpoint/2010/main" val="544852491"/>
       </p:ext>
     </p:extLst>
   </p:cSld>
@@ -19168,7 +19181,7 @@
           <p:cNvPr id="9" name="04 · DISEÑO Y ARQUITECTURA">
             <a:extLst xmlns:a="http://schemas.openxmlformats.org/drawingml/2006/main">
               <a:ext uri="{FF2B5EF4-FFF2-40B4-BE49-F238E27FC236}">
-                <a16:creationId xmlns:a16="http://schemas.microsoft.com/office/drawing/2014/main" id="{84A508E9-79F6-4E80-B7C3-A76C866F7D7B}"/>
+                <a16:creationId xmlns:a16="http://schemas.microsoft.com/office/drawing/2014/main" id="{3BFC473A-ADF8-4A62-969F-33A0D21C6A84}"/>
               </a:ext>
             </a:extLst>
           </p:cNvPr>
@@ -19225,7 +19238,7 @@
           <p:cNvPr id="2" name="Arquitectura del sistema">
             <a:extLst xmlns:a="http://schemas.openxmlformats.org/drawingml/2006/main">
               <a:ext uri="{FF2B5EF4-FFF2-40B4-BE49-F238E27FC236}">
-                <a16:creationId xmlns:a16="http://schemas.microsoft.com/office/drawing/2014/main" id="{2523FC9B-525C-4CD1-9942-F9F62B1F04D0}"/>
+                <a16:creationId xmlns:a16="http://schemas.microsoft.com/office/drawing/2014/main" id="{47A88B2E-D976-4995-928D-7865DA75DE99}"/>
               </a:ext>
             </a:extLst>
           </p:cNvPr>
@@ -19282,7 +19295,7 @@
           <p:cNvPr id="3" name="">
             <a:extLst xmlns:a="http://schemas.openxmlformats.org/drawingml/2006/main">
               <a:ext uri="{FF2B5EF4-FFF2-40B4-BE49-F238E27FC236}">
-                <a16:creationId xmlns:a16="http://schemas.microsoft.com/office/drawing/2014/main" id="{D6A95D36-82D6-4C17-B292-B70C5215C450}"/>
+                <a16:creationId xmlns:a16="http://schemas.microsoft.com/office/drawing/2014/main" id="{5C2F42E9-F88A-4259-A82C-2ADA401C2D47}"/>
               </a:ext>
             </a:extLst>
           </p:cNvPr>
@@ -19312,7 +19325,7 @@
           <p:cNvPr id="4" name="08">
             <a:extLst xmlns:a="http://schemas.openxmlformats.org/drawingml/2006/main">
               <a:ext uri="{FF2B5EF4-FFF2-40B4-BE49-F238E27FC236}">
-                <a16:creationId xmlns:a16="http://schemas.microsoft.com/office/drawing/2014/main" id="{2544299B-2AEE-400F-93C3-DC91259840C9}"/>
+                <a16:creationId xmlns:a16="http://schemas.microsoft.com/office/drawing/2014/main" id="{E8DAE813-7F64-4026-8D7D-7D426C9637A9}"/>
               </a:ext>
             </a:extLst>
           </p:cNvPr>
@@ -19369,7 +19382,7 @@
           <p:cNvPr id="5" name="React + TypeScript     ASP.NET Core / .NET 10     PostgreSQL">
             <a:extLst xmlns:a="http://schemas.openxmlformats.org/drawingml/2006/main">
               <a:ext uri="{FF2B5EF4-FFF2-40B4-BE49-F238E27FC236}">
-                <a16:creationId xmlns:a16="http://schemas.microsoft.com/office/drawing/2014/main" id="{B3BC2E9A-4C01-4313-B237-4FA086DDB224}"/>
+                <a16:creationId xmlns:a16="http://schemas.microsoft.com/office/drawing/2014/main" id="{54F056AA-44FB-4738-93E4-C0A7BD4277EC}"/>
               </a:ext>
             </a:extLst>
           </p:cNvPr>
@@ -19430,7 +19443,7 @@
           <p:nvPr/>
         </p:nvPicPr>
         <p:blipFill>
-          <a:blip xmlns:r="http://schemas.openxmlformats.org/officeDocument/2006/relationships" xmlns:a="http://schemas.openxmlformats.org/drawingml/2006/main" r:embed="R1d5fd7ba0b3f448c"/>
+          <a:blip xmlns:r="http://schemas.openxmlformats.org/officeDocument/2006/relationships" xmlns:a="http://schemas.openxmlformats.org/drawingml/2006/main" r:embed="Re132f26251504292"/>
           <a:stretch xmlns:a="http://schemas.openxmlformats.org/drawingml/2006/main"/>
         </p:blipFill>
         <p:spPr>
@@ -19448,7 +19461,7 @@
           <p:cNvPr id="7" name="La API concentra autorización, validación y reglas de negoci">
             <a:extLst xmlns:a="http://schemas.openxmlformats.org/drawingml/2006/main">
               <a:ext uri="{FF2B5EF4-FFF2-40B4-BE49-F238E27FC236}">
-                <a16:creationId xmlns:a16="http://schemas.microsoft.com/office/drawing/2014/main" id="{915D3D59-0366-4575-BBD3-505554CEB02A}"/>
+                <a16:creationId xmlns:a16="http://schemas.microsoft.com/office/drawing/2014/main" id="{7F72E8B7-A6D4-4B59-9EA4-ADD1DC43E8AE}"/>
               </a:ext>
             </a:extLst>
           </p:cNvPr>
@@ -19505,7 +19518,7 @@
           <p:cNvPr id="8" name="Figura 5.1 de la memoria, p. 22. Nginx mantiene un único ori">
             <a:extLst xmlns:a="http://schemas.openxmlformats.org/drawingml/2006/main">
               <a:ext uri="{FF2B5EF4-FFF2-40B4-BE49-F238E27FC236}">
-                <a16:creationId xmlns:a16="http://schemas.microsoft.com/office/drawing/2014/main" id="{BA273BB9-742C-4587-AC4F-736FC69B378C}"/>
+                <a16:creationId xmlns:a16="http://schemas.microsoft.com/office/drawing/2014/main" id="{363ED46B-D9CB-44C3-8A2B-9F34BF35F125}"/>
               </a:ext>
             </a:extLst>
           </p:cNvPr>
@@ -19560,7 +19573,7 @@
     </p:spTree>
     <p:extLst>
       <p:ext uri="{BB962C8B-B14F-4D97-AF65-F5344CB8AC3E}">
-        <p14:creationId xmlns:p14="http://schemas.microsoft.com/office/powerpoint/2010/main" val="1347805280"/>
+        <p14:creationId xmlns:p14="http://schemas.microsoft.com/office/powerpoint/2010/main" val="1411701622"/>
       </p:ext>
     </p:extLst>
   </p:cSld>
@@ -19591,7 +19604,7 @@
           <p:cNvPr id="12" name="04 · DISEÑO Y ARQUITECTURA">
             <a:extLst xmlns:a="http://schemas.openxmlformats.org/drawingml/2006/main">
               <a:ext uri="{FF2B5EF4-FFF2-40B4-BE49-F238E27FC236}">
-                <a16:creationId xmlns:a16="http://schemas.microsoft.com/office/drawing/2014/main" id="{D602564D-B6E5-46B7-B34D-9BFEAC532D39}"/>
+                <a16:creationId xmlns:a16="http://schemas.microsoft.com/office/drawing/2014/main" id="{3C3B9ECB-CDE8-4F91-92C0-27F19D23C436}"/>
               </a:ext>
             </a:extLst>
           </p:cNvPr>
@@ -19648,7 +19661,7 @@
           <p:cNvPr id="2" name="Modelo y reglas del dominio">
             <a:extLst xmlns:a="http://schemas.openxmlformats.org/drawingml/2006/main">
               <a:ext uri="{FF2B5EF4-FFF2-40B4-BE49-F238E27FC236}">
-                <a16:creationId xmlns:a16="http://schemas.microsoft.com/office/drawing/2014/main" id="{F22CB3A7-9B05-445A-AFC6-3D4021CC5465}"/>
+                <a16:creationId xmlns:a16="http://schemas.microsoft.com/office/drawing/2014/main" id="{D13ACC95-B299-495C-B8BA-446585E35A0F}"/>
               </a:ext>
             </a:extLst>
           </p:cNvPr>
@@ -19705,7 +19718,7 @@
           <p:cNvPr id="3" name="">
             <a:extLst xmlns:a="http://schemas.openxmlformats.org/drawingml/2006/main">
               <a:ext uri="{FF2B5EF4-FFF2-40B4-BE49-F238E27FC236}">
-                <a16:creationId xmlns:a16="http://schemas.microsoft.com/office/drawing/2014/main" id="{F927BFCA-7C3E-427C-9ABE-6D80CF3B41E6}"/>
+                <a16:creationId xmlns:a16="http://schemas.microsoft.com/office/drawing/2014/main" id="{636D93A9-FA64-4CBB-AC25-FCABB5AAFA49}"/>
               </a:ext>
             </a:extLst>
           </p:cNvPr>
@@ -19735,7 +19748,7 @@
           <p:cNvPr id="4" name="09">
             <a:extLst xmlns:a="http://schemas.openxmlformats.org/drawingml/2006/main">
               <a:ext uri="{FF2B5EF4-FFF2-40B4-BE49-F238E27FC236}">
-                <a16:creationId xmlns:a16="http://schemas.microsoft.com/office/drawing/2014/main" id="{10BAFAB9-2856-4F12-86D0-6FDCF676456A}"/>
+                <a16:creationId xmlns:a16="http://schemas.microsoft.com/office/drawing/2014/main" id="{44BC56A8-0780-439A-9A6B-D459CEC2FD9F}"/>
               </a:ext>
             </a:extLst>
           </p:cNvPr>
@@ -19796,7 +19809,7 @@
           <p:nvPr/>
         </p:nvPicPr>
         <p:blipFill>
-          <a:blip xmlns:r="http://schemas.openxmlformats.org/officeDocument/2006/relationships" xmlns:a="http://schemas.openxmlformats.org/drawingml/2006/main" r:embed="Ra57e564962924963"/>
+          <a:blip xmlns:r="http://schemas.openxmlformats.org/officeDocument/2006/relationships" xmlns:a="http://schemas.openxmlformats.org/drawingml/2006/main" r:embed="R7ba88d8a47644a53"/>
           <a:stretch xmlns:a="http://schemas.openxmlformats.org/drawingml/2006/main"/>
         </p:blipFill>
         <p:spPr>
@@ -19814,7 +19827,7 @@
           <p:cNvPr id="6" name="Envío como núcleo">
             <a:extLst xmlns:a="http://schemas.openxmlformats.org/drawingml/2006/main">
               <a:ext uri="{FF2B5EF4-FFF2-40B4-BE49-F238E27FC236}">
-                <a16:creationId xmlns:a16="http://schemas.microsoft.com/office/drawing/2014/main" id="{534D0814-3A68-4A7F-843D-2EB2B0CDDFF7}"/>
+                <a16:creationId xmlns:a16="http://schemas.microsoft.com/office/drawing/2014/main" id="{FE09C57D-5E36-4A0A-AB9D-1D6E4C0EDA29}"/>
               </a:ext>
             </a:extLst>
           </p:cNvPr>
@@ -19871,7 +19884,7 @@
           <p:cNvPr id="7" name="Cliente opcional y pareja de vehículo y conductor.">
             <a:extLst xmlns:a="http://schemas.openxmlformats.org/drawingml/2006/main">
               <a:ext uri="{FF2B5EF4-FFF2-40B4-BE49-F238E27FC236}">
-                <a16:creationId xmlns:a16="http://schemas.microsoft.com/office/drawing/2014/main" id="{E019B210-296D-47B5-B2DE-1A89C167101E}"/>
+                <a16:creationId xmlns:a16="http://schemas.microsoft.com/office/drawing/2014/main" id="{B7C3DF74-68FA-4DA8-8036-3D66E2C72991}"/>
               </a:ext>
             </a:extLst>
           </p:cNvPr>
@@ -19928,7 +19941,7 @@
           <p:cNvPr id="8" name="Historia preservada">
             <a:extLst xmlns:a="http://schemas.openxmlformats.org/drawingml/2006/main">
               <a:ext uri="{FF2B5EF4-FFF2-40B4-BE49-F238E27FC236}">
-                <a16:creationId xmlns:a16="http://schemas.microsoft.com/office/drawing/2014/main" id="{A2494992-0234-4A33-BD7B-6CAE24AA562F}"/>
+                <a16:creationId xmlns:a16="http://schemas.microsoft.com/office/drawing/2014/main" id="{027D44BF-5E73-443A-8396-33B641EF8185}"/>
               </a:ext>
             </a:extLst>
           </p:cNvPr>
@@ -19985,7 +19998,7 @@
           <p:cNvPr id="9" name="Baja lógica en catálogos y usuarios. Eventos sin edición ni ">
             <a:extLst xmlns:a="http://schemas.openxmlformats.org/drawingml/2006/main">
               <a:ext uri="{FF2B5EF4-FFF2-40B4-BE49-F238E27FC236}">
-                <a16:creationId xmlns:a16="http://schemas.microsoft.com/office/drawing/2014/main" id="{AC71B4C1-29A3-4458-A399-5F701A1C5BD0}"/>
+                <a16:creationId xmlns:a16="http://schemas.microsoft.com/office/drawing/2014/main" id="{B3F8B052-8A89-4570-A147-4812E00C259A}"/>
               </a:ext>
             </a:extLst>
           </p:cNvPr>
@@ -20042,7 +20055,7 @@
           <p:cNvPr id="10" name="Las invariantes críticas también se refuerzan en PostgreSQL">
             <a:extLst xmlns:a="http://schemas.openxmlformats.org/drawingml/2006/main">
               <a:ext uri="{FF2B5EF4-FFF2-40B4-BE49-F238E27FC236}">
-                <a16:creationId xmlns:a16="http://schemas.microsoft.com/office/drawing/2014/main" id="{FDF533D4-F540-42EA-A034-4DBCA075E13E}"/>
+                <a16:creationId xmlns:a16="http://schemas.microsoft.com/office/drawing/2014/main" id="{C836E49B-34E8-4937-8F56-E9799D6B37D3}"/>
               </a:ext>
             </a:extLst>
           </p:cNvPr>
@@ -20099,7 +20112,7 @@
           <p:cNvPr id="11" name="Figura 5.2, p. 23. Esquema resumido, sin todos los campos e ">
             <a:extLst xmlns:a="http://schemas.openxmlformats.org/drawingml/2006/main">
               <a:ext uri="{FF2B5EF4-FFF2-40B4-BE49-F238E27FC236}">
-                <a16:creationId xmlns:a16="http://schemas.microsoft.com/office/drawing/2014/main" id="{A135282C-789E-4F75-9638-463E02E3DC03}"/>
+                <a16:creationId xmlns:a16="http://schemas.microsoft.com/office/drawing/2014/main" id="{70118891-CD79-4DB1-A2EF-E536AA9B0520}"/>
               </a:ext>
             </a:extLst>
           </p:cNvPr>
@@ -20154,7 +20167,7 @@
     </p:spTree>
     <p:extLst>
       <p:ext uri="{BB962C8B-B14F-4D97-AF65-F5344CB8AC3E}">
-        <p14:creationId xmlns:p14="http://schemas.microsoft.com/office/powerpoint/2010/main" val="534395191"/>
+        <p14:creationId xmlns:p14="http://schemas.microsoft.com/office/powerpoint/2010/main" val="1180626531"/>
       </p:ext>
     </p:extLst>
   </p:cSld>

</xml_diff>